<commit_message>
Update slides to match v4 doc: remove unverified figure, add market-entry framing and pricing structure
Co-Authored-By: Claude Sonnet 5 <noreply@anthropic.com>
Claude-Session: https://claude.ai/code/session_018Bg71BX6us34ZYpqiy24Sa
</commit_message>
<xml_diff>
--- a/STRIVE_Capstone_Christian_Slides.pptx
+++ b/STRIVE_Capstone_Christian_Slides.pptx
@@ -3112,7 +3112,7 @@
           <a:lstStyle/>
           <a:p>
             <a:r>
-              <a:rPr sz="2800" b="1">
+              <a:rPr sz="2600" b="1">
                 <a:solidFill>
                   <a:srgbClr val="1B2A5E"/>
                 </a:solidFill>
@@ -3132,7 +3132,7 @@
         <p:spPr>
           <a:xfrm>
             <a:off x="457200" y="914400"/>
-            <a:ext cx="11247120" cy="457200"/>
+            <a:ext cx="11247120" cy="365760"/>
           </a:xfrm>
           <a:prstGeom prst="rect">
             <a:avLst/>
@@ -3148,11 +3148,11 @@
             <a:r>
               <a:rPr sz="1400" i="1">
                 <a:solidFill>
-                  <a:srgbClr val="555555"/>
+                  <a:srgbClr val="777777"/>
                 </a:solidFill>
                 <a:latin typeface="Arial"/>
               </a:rPr>
-              <a:t>Ranked on cost, ease of implementation, timeframe, and impact — not relationship strength alone</a:t>
+              <a:t>Ranked on cost, ease of implementation, timeframe, and impact</a:t>
             </a:r>
           </a:p>
         </p:txBody>
@@ -3166,8 +3166,8 @@
           <p:nvPr/>
         </p:nvGraphicFramePr>
         <p:xfrm>
-          <a:off x="457200" y="1463040"/>
-          <a:ext cx="11247120" cy="2011680"/>
+          <a:off x="457200" y="1371600"/>
+          <a:ext cx="11247120" cy="1828800"/>
         </p:xfrm>
         <a:graphic>
           <a:graphicData uri="http://schemas.openxmlformats.org/drawingml/2006/table">
@@ -3176,20 +3176,20 @@
                 <a:tableStyleId>{5C22544A-7EE6-4342-B048-85BDC9FD1C3A}</a:tableStyleId>
               </a:tblPr>
               <a:tblGrid>
-                <a:gridCol w="1645920"/>
-                <a:gridCol w="2560320"/>
-                <a:gridCol w="1463040"/>
-                <a:gridCol w="4023360"/>
                 <a:gridCol w="1554480"/>
+                <a:gridCol w="2377440"/>
+                <a:gridCol w="2651760"/>
+                <a:gridCol w="3291840"/>
+                <a:gridCol w="1371600"/>
               </a:tblGrid>
-              <a:tr h="502920">
+              <a:tr h="457200">
                 <a:tc>
                   <a:txBody>
                     <a:bodyPr/>
                     <a:lstStyle/>
                     <a:p>
-                      <a:pPr algn="l">
-                        <a:defRPr sz="1200" b="1">
+                      <a:pPr>
+                        <a:defRPr sz="1100" b="1">
                           <a:solidFill>
                             <a:srgbClr val="FFFFFF"/>
                           </a:solidFill>
@@ -3212,8 +3212,32 @@
                     <a:bodyPr/>
                     <a:lstStyle/>
                     <a:p>
-                      <a:pPr algn="l">
-                        <a:defRPr sz="1200" b="1">
+                      <a:pPr>
+                        <a:defRPr sz="1100" b="1">
+                          <a:solidFill>
+                            <a:srgbClr val="FFFFFF"/>
+                          </a:solidFill>
+                          <a:latin typeface="Arial"/>
+                        </a:defRPr>
+                      </a:pPr>
+                      <a:r>
+                        <a:t>APTIM Relationship</a:t>
+                      </a:r>
+                    </a:p>
+                  </a:txBody>
+                  <a:tcPr>
+                    <a:solidFill>
+                      <a:srgbClr val="1B2A5E"/>
+                    </a:solidFill>
+                  </a:tcPr>
+                </a:tc>
+                <a:tc>
+                  <a:txBody>
+                    <a:bodyPr/>
+                    <a:lstStyle/>
+                    <a:p>
+                      <a:pPr>
+                        <a:defRPr sz="1100" b="1">
                           <a:solidFill>
                             <a:srgbClr val="FFFFFF"/>
                           </a:solidFill>
@@ -3236,32 +3260,8 @@
                     <a:bodyPr/>
                     <a:lstStyle/>
                     <a:p>
-                      <a:pPr algn="l">
-                        <a:defRPr sz="1200" b="1">
-                          <a:solidFill>
-                            <a:srgbClr val="FFFFFF"/>
-                          </a:solidFill>
-                          <a:latin typeface="Arial"/>
-                        </a:defRPr>
-                      </a:pPr>
-                      <a:r>
-                        <a:t>Timeframe</a:t>
-                      </a:r>
-                    </a:p>
-                  </a:txBody>
-                  <a:tcPr>
-                    <a:solidFill>
-                      <a:srgbClr val="1B2A5E"/>
-                    </a:solidFill>
-                  </a:tcPr>
-                </a:tc>
-                <a:tc>
-                  <a:txBody>
-                    <a:bodyPr/>
-                    <a:lstStyle/>
-                    <a:p>
-                      <a:pPr algn="l">
-                        <a:defRPr sz="1200" b="1">
+                      <a:pPr>
+                        <a:defRPr sz="1100" b="1">
                           <a:solidFill>
                             <a:srgbClr val="FFFFFF"/>
                           </a:solidFill>
@@ -3284,8 +3284,8 @@
                     <a:bodyPr/>
                     <a:lstStyle/>
                     <a:p>
-                      <a:pPr algn="l">
-                        <a:defRPr sz="1200" b="1">
+                      <a:pPr>
+                        <a:defRPr sz="1100" b="1">
                           <a:solidFill>
                             <a:srgbClr val="FFFFFF"/>
                           </a:solidFill>
@@ -3304,14 +3304,14 @@
                   </a:tcPr>
                 </a:tc>
               </a:tr>
-              <a:tr h="502920">
+              <a:tr h="457200">
                 <a:tc>
                   <a:txBody>
                     <a:bodyPr/>
                     <a:lstStyle/>
                     <a:p>
                       <a:pPr>
-                        <a:defRPr sz="1200">
+                        <a:defRPr sz="1100">
                           <a:solidFill>
                             <a:srgbClr val="333333"/>
                           </a:solidFill>
@@ -3335,7 +3335,7 @@
                     <a:lstStyle/>
                     <a:p>
                       <a:pPr>
-                        <a:defRPr sz="1200">
+                        <a:defRPr sz="1100">
                           <a:solidFill>
                             <a:srgbClr val="333333"/>
                           </a:solidFill>
@@ -3343,7 +3343,7 @@
                         </a:defRPr>
                       </a:pPr>
                       <a:r>
-                        <a:t>High — mature market, proven model</a:t>
+                        <a:t>None — reference market</a:t>
                       </a:r>
                     </a:p>
                   </a:txBody>
@@ -3359,7 +3359,7 @@
                     <a:lstStyle/>
                     <a:p>
                       <a:pPr>
-                        <a:defRPr sz="1200">
+                        <a:defRPr sz="1100">
                           <a:solidFill>
                             <a:srgbClr val="333333"/>
                           </a:solidFill>
@@ -3367,7 +3367,7 @@
                         </a:defRPr>
                       </a:pPr>
                       <a:r>
-                        <a:t>Immediate</a:t>
+                        <a:t>High — mature, proven model</a:t>
                       </a:r>
                     </a:p>
                   </a:txBody>
@@ -3383,7 +3383,7 @@
                     <a:lstStyle/>
                     <a:p>
                       <a:pPr>
-                        <a:defRPr sz="1200">
+                        <a:defRPr sz="1100">
                           <a:solidFill>
                             <a:srgbClr val="333333"/>
                           </a:solidFill>
@@ -3407,7 +3407,7 @@
                     <a:lstStyle/>
                     <a:p>
                       <a:pPr>
-                        <a:defRPr sz="1200">
+                        <a:defRPr sz="1100">
                           <a:solidFill>
                             <a:srgbClr val="333333"/>
                           </a:solidFill>
@@ -3426,14 +3426,14 @@
                   </a:tcPr>
                 </a:tc>
               </a:tr>
-              <a:tr h="502920">
+              <a:tr h="457200">
                 <a:tc>
                   <a:txBody>
                     <a:bodyPr/>
                     <a:lstStyle/>
                     <a:p>
                       <a:pPr>
-                        <a:defRPr sz="1200">
+                        <a:defRPr sz="1100">
                           <a:solidFill>
                             <a:srgbClr val="333333"/>
                           </a:solidFill>
@@ -3457,7 +3457,7 @@
                     <a:lstStyle/>
                     <a:p>
                       <a:pPr>
-                        <a:defRPr sz="1200">
+                        <a:defRPr sz="1100">
                           <a:solidFill>
                             <a:srgbClr val="333333"/>
                           </a:solidFill>
@@ -3465,7 +3465,7 @@
                         </a:defRPr>
                       </a:pPr>
                       <a:r>
-                        <a:t>Medium — Duke already moving this direction</a:t>
+                        <a:t>None — reference market</a:t>
                       </a:r>
                     </a:p>
                   </a:txBody>
@@ -3481,7 +3481,7 @@
                     <a:lstStyle/>
                     <a:p>
                       <a:pPr>
-                        <a:defRPr sz="1200">
+                        <a:defRPr sz="1100">
                           <a:solidFill>
                             <a:srgbClr val="333333"/>
                           </a:solidFill>
@@ -3489,7 +3489,7 @@
                         </a:defRPr>
                       </a:pPr>
                       <a:r>
-                        <a:t>1-2 years</a:t>
+                        <a:t>Medium — Duke moving this direction</a:t>
                       </a:r>
                     </a:p>
                   </a:txBody>
@@ -3505,7 +3505,7 @@
                     <a:lstStyle/>
                     <a:p>
                       <a:pPr>
-                        <a:defRPr sz="1200">
+                        <a:defRPr sz="1100">
                           <a:solidFill>
                             <a:srgbClr val="333333"/>
                           </a:solidFill>
@@ -3513,7 +3513,7 @@
                         </a:defRPr>
                       </a:pPr>
                       <a:r>
-                        <a:t>Demonstrates real customer demand (PowerPair waitlisted)</a:t>
+                        <a:t>PowerPair fully subscribed/waitlisted — proves demand</a:t>
                       </a:r>
                     </a:p>
                   </a:txBody>
@@ -3529,7 +3529,7 @@
                     <a:lstStyle/>
                     <a:p>
                       <a:pPr>
-                        <a:defRPr sz="1200">
+                        <a:defRPr sz="1100">
                           <a:solidFill>
                             <a:srgbClr val="333333"/>
                           </a:solidFill>
@@ -3548,14 +3548,14 @@
                   </a:tcPr>
                 </a:tc>
               </a:tr>
-              <a:tr h="502920">
+              <a:tr h="457200">
                 <a:tc>
                   <a:txBody>
                     <a:bodyPr/>
                     <a:lstStyle/>
                     <a:p>
                       <a:pPr>
-                        <a:defRPr sz="1200">
+                        <a:defRPr sz="1100">
                           <a:solidFill>
                             <a:srgbClr val="333333"/>
                           </a:solidFill>
@@ -3579,7 +3579,31 @@
                     <a:lstStyle/>
                     <a:p>
                       <a:pPr>
-                        <a:defRPr sz="1200">
+                        <a:defRPr sz="1100">
+                          <a:solidFill>
+                            <a:srgbClr val="333333"/>
+                          </a:solidFill>
+                          <a:latin typeface="Arial"/>
+                        </a:defRPr>
+                      </a:pPr>
+                      <a:r>
+                        <a:t>None confirmed — market-entry pitch</a:t>
+                      </a:r>
+                    </a:p>
+                  </a:txBody>
+                  <a:tcPr>
+                    <a:solidFill>
+                      <a:srgbClr val="F2F4F8"/>
+                    </a:solidFill>
+                  </a:tcPr>
+                </a:tc>
+                <a:tc>
+                  <a:txBody>
+                    <a:bodyPr/>
+                    <a:lstStyle/>
+                    <a:p>
+                      <a:pPr>
+                        <a:defRPr sz="1100">
                           <a:solidFill>
                             <a:srgbClr val="333333"/>
                           </a:solidFill>
@@ -3603,7 +3627,7 @@
                     <a:lstStyle/>
                     <a:p>
                       <a:pPr>
-                        <a:defRPr sz="1200">
+                        <a:defRPr sz="1100">
                           <a:solidFill>
                             <a:srgbClr val="333333"/>
                           </a:solidFill>
@@ -3611,7 +3635,7 @@
                         </a:defRPr>
                       </a:pPr>
                       <a:r>
-                        <a:t>Year 1 pilot</a:t>
+                        <a:t>Worst outages in nation + 2,500 MW storage mandate (2029 deadline)</a:t>
                       </a:r>
                     </a:p>
                   </a:txBody>
@@ -3627,31 +3651,7 @@
                     <a:lstStyle/>
                     <a:p>
                       <a:pPr>
-                        <a:defRPr sz="1200">
-                          <a:solidFill>
-                            <a:srgbClr val="333333"/>
-                          </a:solidFill>
-                          <a:latin typeface="Arial"/>
-                        </a:defRPr>
-                      </a:pPr>
-                      <a:r>
-                        <a:t>Worst outages in the nation + 2,500 MW storage mandate (2029 deadline)</a:t>
-                      </a:r>
-                    </a:p>
-                  </a:txBody>
-                  <a:tcPr>
-                    <a:solidFill>
-                      <a:srgbClr val="F2F4F8"/>
-                    </a:solidFill>
-                  </a:tcPr>
-                </a:tc>
-                <a:tc>
-                  <a:txBody>
-                    <a:bodyPr/>
-                    <a:lstStyle/>
-                    <a:p>
-                      <a:pPr>
-                        <a:defRPr sz="1200">
+                        <a:defRPr sz="1100">
                           <a:solidFill>
                             <a:srgbClr val="333333"/>
                           </a:solidFill>
@@ -3682,8 +3682,62 @@
         </p:nvSpPr>
         <p:spPr>
           <a:xfrm>
-            <a:off x="457200" y="3749039"/>
-            <a:ext cx="11247120" cy="2286000"/>
+            <a:off x="457200" y="3337560"/>
+            <a:ext cx="11247120" cy="502920"/>
+          </a:xfrm>
+          <a:prstGeom prst="rect">
+            <a:avLst/>
+          </a:prstGeom>
+          <a:solidFill>
+            <a:srgbClr val="FFF6E8"/>
+          </a:solidFill>
+          <a:ln w="12700">
+            <a:solidFill>
+              <a:srgbClr val="E87B22"/>
+            </a:solidFill>
+          </a:ln>
+        </p:spPr>
+        <p:style>
+          <a:lnRef idx="1">
+            <a:schemeClr val="accent1"/>
+          </a:lnRef>
+          <a:fillRef idx="3">
+            <a:schemeClr val="accent1"/>
+          </a:fillRef>
+          <a:effectRef idx="2">
+            <a:schemeClr val="accent1"/>
+          </a:effectRef>
+          <a:fontRef idx="minor">
+            <a:schemeClr val="lt1"/>
+          </a:fontRef>
+        </p:style>
+        <p:txBody>
+          <a:bodyPr rtlCol="0" anchor="ctr" wrap="square" lIns="137160" tIns="91440"/>
+          <a:lstStyle/>
+          <a:p>
+            <a:pPr algn="ctr"/>
+            <a:r>
+              <a:rPr sz="1100" i="1">
+                <a:solidFill>
+                  <a:srgbClr val="664E1A"/>
+                </a:solidFill>
+                <a:latin typeface="Arial"/>
+              </a:rPr>
+              <a:t>Note: APTIM has no confirmed existing contract in any of these three states for this exact program. This is a market-entry pitch built on regulatory/economic fit, not incumbency — unlike our Wisconsin and Louisiana relationships, held as expansion options.</a:t>
+            </a:r>
+          </a:p>
+        </p:txBody>
+      </p:sp>
+      <p:sp>
+        <p:nvSpPr>
+          <p:cNvPr id="6" name="Rectangle 5"/>
+          <p:cNvSpPr/>
+          <p:nvPr/>
+        </p:nvSpPr>
+        <p:spPr>
+          <a:xfrm>
+            <a:off x="457200" y="3977639"/>
+            <a:ext cx="11247120" cy="1965960"/>
           </a:xfrm>
           <a:prstGeom prst="rect">
             <a:avLst/>
@@ -3717,23 +3771,23 @@
           <a:p>
             <a:pPr algn="ctr"/>
             <a:r>
-              <a:rPr b="1" sz="1600">
+              <a:rPr b="1" sz="1500">
                 <a:solidFill>
                   <a:srgbClr val="1B2A5E"/>
                 </a:solidFill>
                 <a:latin typeface="Arial"/>
               </a:rPr>
-              <a:t>Why Michigan Wins on the Numbers</a:t>
+              <a:t>Why Michigan — Sourced Evidence</a:t>
             </a:r>
           </a:p>
           <a:p>
             <a:pPr>
               <a:spcAft>
-                <a:spcPts val="400"/>
+                <a:spcPts val="300"/>
               </a:spcAft>
             </a:pPr>
             <a:r>
-              <a:rPr b="1" sz="1300">
+              <a:rPr b="1" sz="1200">
                 <a:solidFill>
                   <a:srgbClr val="E87B22"/>
                 </a:solidFill>
@@ -3742,23 +3796,23 @@
               <a:t>Reliability: </a:t>
             </a:r>
             <a:r>
-              <a:rPr sz="1300">
+              <a:rPr sz="1200">
                 <a:solidFill>
                   <a:srgbClr val="333333"/>
                 </a:solidFill>
                 <a:latin typeface="Arial"/>
               </a:rPr>
-              <a:t>50th of 51 states in outage duration (~18 hrs/customer/yr) — and outages are distribution-level, exactly what a home battery covers.</a:t>
+              <a:t>50th of 51 states in outage duration — and outages are distribution-level, exactly what a home battery covers.</a:t>
             </a:r>
           </a:p>
           <a:p>
             <a:pPr>
               <a:spcAft>
-                <a:spcPts val="400"/>
+                <a:spcPts val="300"/>
               </a:spcAft>
             </a:pPr>
             <a:r>
-              <a:rPr b="1" sz="1300">
+              <a:rPr b="1" sz="1200">
                 <a:solidFill>
                   <a:srgbClr val="E87B22"/>
                 </a:solidFill>
@@ -3767,76 +3821,76 @@
               <a:t>Policy hook: </a:t>
             </a:r>
             <a:r>
-              <a:rPr sz="1300">
+              <a:rPr sz="1200">
                 <a:solidFill>
                   <a:srgbClr val="333333"/>
                 </a:solidFill>
                 <a:latin typeface="Arial"/>
               </a:rPr>
-              <a:t>2023 state law (PA 235) mandates 2,500 MW of storage with utility compliance filings due by 2029 — a ready-made rate-basing vehicle.</a:t>
+              <a:t>PA 235 (2023) mandates 2,500 MW of storage; MPSC Case No. U-21571 sets compliance petitions due Dec 31, 2029.</a:t>
             </a:r>
           </a:p>
           <a:p>
             <a:pPr>
               <a:spcAft>
-                <a:spcPts val="400"/>
+                <a:spcPts val="300"/>
               </a:spcAft>
             </a:pPr>
             <a:r>
-              <a:rPr b="1" sz="1300">
+              <a:rPr b="1" sz="1200">
                 <a:solidFill>
                   <a:srgbClr val="E87B22"/>
                 </a:solidFill>
                 <a:latin typeface="Arial"/>
               </a:rPr>
-              <a:t>Ownership structure: </a:t>
-            </a:r>
-            <a:r>
-              <a:rPr sz="1300">
+              <a:t>Utility need: </a:t>
+            </a:r>
+            <a:r>
+              <a:rPr sz="1200">
                 <a:solidFill>
                   <a:srgbClr val="333333"/>
                 </a:solidFill>
                 <a:latin typeface="Arial"/>
               </a:rPr>
-              <a:t>DTE and Consumers are vertically integrated and can legally rate-base batteries directly (unlike deregulated Illinois).</a:t>
+              <a:t>DTE IRP (Case U-21193) cites 850+ MW storage need; Consumers IRP (Case U-21090) targets 75 MW by 2027, 550 MW by 2040.</a:t>
             </a:r>
           </a:p>
           <a:p>
             <a:pPr>
               <a:spcAft>
-                <a:spcPts val="400"/>
+                <a:spcPts val="300"/>
               </a:spcAft>
             </a:pPr>
             <a:r>
-              <a:rPr b="1" sz="1300">
+              <a:rPr b="1" sz="1200">
                 <a:solidFill>
                   <a:srgbClr val="E87B22"/>
                 </a:solidFill>
                 <a:latin typeface="Arial"/>
               </a:rPr>
-              <a:t>Competition: </a:t>
-            </a:r>
-            <a:r>
-              <a:rPr sz="1300">
+              <a:t>Capacity value: </a:t>
+            </a:r>
+            <a:r>
+              <a:rPr sz="1200">
                 <a:solidFill>
                   <a:srgbClr val="333333"/>
                 </a:solidFill>
                 <a:latin typeface="Arial"/>
               </a:rPr>
-              <a:t>Near-greenfield — one small pilot exists; no scaled residential program.</a:t>
-            </a:r>
-          </a:p>
-        </p:txBody>
-      </p:sp>
-      <p:sp>
-        <p:nvSpPr>
-          <p:cNvPr id="6" name="TextBox 5"/>
+              <a:t>MISO cleared Michigan's zone at $424.30/MW-day for 2026/27 (source: MISO PRA posting) — real, dated, verifiable market signal.</a:t>
+            </a:r>
+          </a:p>
+        </p:txBody>
+      </p:sp>
+      <p:sp>
+        <p:nvSpPr>
+          <p:cNvPr id="7" name="TextBox 6"/>
           <p:cNvSpPr txBox="1"/>
           <p:nvPr/>
         </p:nvSpPr>
         <p:spPr>
           <a:xfrm>
-            <a:off x="457200" y="6172200"/>
+            <a:off x="457200" y="6080760"/>
             <a:ext cx="11247120" cy="365760"/>
           </a:xfrm>
           <a:prstGeom prst="rect">
@@ -3857,14 +3911,14 @@
                 </a:solidFill>
                 <a:latin typeface="Arial"/>
               </a:rPr>
-              <a:t>Note: Wisconsin (strongest APTIM relationship) and Illinois (best raw capacity pricing) were evaluated and held as expansion markets — see appendix.</a:t>
-            </a:r>
-          </a:p>
-        </p:txBody>
-      </p:sp>
-      <p:sp>
-        <p:nvSpPr>
-          <p:cNvPr id="7" name="TextBox 6"/>
+              <a:t>Wisconsin (strongest APTIM relationship, weaker economics) and Illinois (best raw pricing, legally blocked for utility ownership) were evaluated and held as separate opportunities.</a:t>
+            </a:r>
+          </a:p>
+        </p:txBody>
+      </p:sp>
+      <p:sp>
+        <p:nvSpPr>
+          <p:cNvPr id="8" name="TextBox 7"/>
           <p:cNvSpPr txBox="1"/>
           <p:nvPr/>
         </p:nvSpPr>
@@ -3898,7 +3952,7 @@
       </p:sp>
       <p:sp>
         <p:nvSpPr>
-          <p:cNvPr id="8" name="TextBox 7"/>
+          <p:cNvPr id="9" name="TextBox 8"/>
           <p:cNvSpPr txBox="1"/>
           <p:nvPr/>
         </p:nvSpPr>
@@ -3971,7 +4025,7 @@
           <a:lstStyle/>
           <a:p>
             <a:r>
-              <a:rPr sz="2800" b="1">
+              <a:rPr sz="2600" b="1">
                 <a:solidFill>
                   <a:srgbClr val="1B2A5E"/>
                 </a:solidFill>
@@ -3991,7 +4045,7 @@
         <p:spPr>
           <a:xfrm>
             <a:off x="457200" y="914400"/>
-            <a:ext cx="11247120" cy="457200"/>
+            <a:ext cx="11247120" cy="365760"/>
           </a:xfrm>
           <a:prstGeom prst="rect">
             <a:avLst/>
@@ -4007,11 +4061,11 @@
             <a:r>
               <a:rPr sz="1400" i="1">
                 <a:solidFill>
-                  <a:srgbClr val="555555"/>
+                  <a:srgbClr val="777777"/>
                 </a:solidFill>
                 <a:latin typeface="Arial"/>
               </a:rPr>
-              <a:t>The utility owns the fleet. APTIM administers it. The customer pays nothing.</a:t>
+              <a:t>The utility owns the fleet. APTIM administers it. The household hosts it at no cost.</a:t>
             </a:r>
           </a:p>
         </p:txBody>
@@ -4024,8 +4078,8 @@
         </p:nvSpPr>
         <p:spPr>
           <a:xfrm>
-            <a:off x="457200" y="1508760"/>
-            <a:ext cx="3520440" cy="1737360"/>
+            <a:off x="457200" y="1371600"/>
+            <a:ext cx="3520440" cy="1554480"/>
           </a:xfrm>
           <a:prstGeom prst="rect">
             <a:avLst/>
@@ -4052,12 +4106,12 @@
           </a:fontRef>
         </p:style>
         <p:txBody>
-          <a:bodyPr rtlCol="0" anchor="ctr" wrap="square" lIns="137160" tIns="137160" rIns="137160"/>
+          <a:bodyPr rtlCol="0" anchor="ctr" wrap="square" lIns="137160" tIns="109728" rIns="137160"/>
           <a:lstStyle/>
           <a:p>
             <a:pPr algn="ctr"/>
             <a:r>
-              <a:rPr b="1" sz="1400">
+              <a:rPr b="1" sz="1300">
                 <a:solidFill>
                   <a:srgbClr val="FFFFFF"/>
                 </a:solidFill>
@@ -4069,25 +4123,25 @@
           <a:p>
             <a:pPr algn="ctr"/>
             <a:r>
-              <a:rPr b="1" sz="1300">
+              <a:rPr b="1" sz="1200">
                 <a:solidFill>
                   <a:srgbClr val="FFFFFF"/>
                 </a:solidFill>
                 <a:latin typeface="Arial"/>
               </a:rPr>
-              <a:t>Tesla / Enphase / equivalent</a:t>
+              <a:t>e.g., Tesla, Enphase</a:t>
             </a:r>
           </a:p>
           <a:p>
             <a:pPr algn="ctr"/>
             <a:r>
-              <a:rPr sz="1100">
+              <a:rPr sz="1000">
                 <a:solidFill>
                   <a:srgbClr val="FFFFFF"/>
                 </a:solidFill>
                 <a:latin typeface="Arial"/>
               </a:rPr>
-              <a:t>Makes the physical battery + solar hardware</a:t>
+              <a:t>Manufactures the battery + solar hardware</a:t>
             </a:r>
           </a:p>
         </p:txBody>
@@ -4100,8 +4154,8 @@
         </p:nvSpPr>
         <p:spPr>
           <a:xfrm>
-            <a:off x="4114800" y="1508760"/>
-            <a:ext cx="3520440" cy="1737360"/>
+            <a:off x="4114800" y="1371600"/>
+            <a:ext cx="3520440" cy="1554480"/>
           </a:xfrm>
           <a:prstGeom prst="rect">
             <a:avLst/>
@@ -4128,12 +4182,12 @@
           </a:fontRef>
         </p:style>
         <p:txBody>
-          <a:bodyPr rtlCol="0" anchor="ctr" wrap="square" lIns="137160" tIns="137160" rIns="137160"/>
+          <a:bodyPr rtlCol="0" anchor="ctr" wrap="square" lIns="137160" tIns="109728" rIns="137160"/>
           <a:lstStyle/>
           <a:p>
             <a:pPr algn="ctr"/>
             <a:r>
-              <a:rPr b="1" sz="1400">
+              <a:rPr b="1" sz="1300">
                 <a:solidFill>
                   <a:srgbClr val="FFFFFF"/>
                 </a:solidFill>
@@ -4145,7 +4199,7 @@
           <a:p>
             <a:pPr algn="ctr"/>
             <a:r>
-              <a:rPr b="1" sz="1300">
+              <a:rPr b="1" sz="1200">
                 <a:solidFill>
                   <a:srgbClr val="FFFFFF"/>
                 </a:solidFill>
@@ -4157,13 +4211,13 @@
           <a:p>
             <a:pPr algn="ctr"/>
             <a:r>
-              <a:rPr sz="1100">
+              <a:rPr sz="1000">
                 <a:solidFill>
                   <a:srgbClr val="FFFFFF"/>
                 </a:solidFill>
                 <a:latin typeface="Arial"/>
               </a:rPr>
-              <a:t>Finances, owns, and rate-bases the fleet as grid infrastructure; dispatches via Tesla/EnergyHub software; captures avoided peak-capacity value ($500-$1,500/kW)</a:t>
+              <a:t>Finances, owns, and rate-bases the fleet; recovers cost from all ratepayers; earns regulated return; dispatches at peak via utility or partner software</a:t>
             </a:r>
           </a:p>
         </p:txBody>
@@ -4176,8 +4230,8 @@
         </p:nvSpPr>
         <p:spPr>
           <a:xfrm>
-            <a:off x="7772400" y="1508760"/>
-            <a:ext cx="3520440" cy="1737360"/>
+            <a:off x="7772400" y="1371600"/>
+            <a:ext cx="3520440" cy="1554480"/>
           </a:xfrm>
           <a:prstGeom prst="rect">
             <a:avLst/>
@@ -4204,12 +4258,12 @@
           </a:fontRef>
         </p:style>
         <p:txBody>
-          <a:bodyPr rtlCol="0" anchor="ctr" wrap="square" lIns="137160" tIns="137160" rIns="137160"/>
+          <a:bodyPr rtlCol="0" anchor="ctr" wrap="square" lIns="137160" tIns="109728" rIns="137160"/>
           <a:lstStyle/>
           <a:p>
             <a:pPr algn="ctr"/>
             <a:r>
-              <a:rPr b="1" sz="1400">
+              <a:rPr b="1" sz="1300">
                 <a:solidFill>
                   <a:srgbClr val="FFFFFF"/>
                 </a:solidFill>
@@ -4221,7 +4275,7 @@
           <a:p>
             <a:pPr algn="ctr"/>
             <a:r>
-              <a:rPr b="1" sz="1300">
+              <a:rPr b="1" sz="1200">
                 <a:solidFill>
                   <a:srgbClr val="FFFFFF"/>
                 </a:solidFill>
@@ -4233,13 +4287,13 @@
           <a:p>
             <a:pPr algn="ctr"/>
             <a:r>
-              <a:rPr sz="1100">
+              <a:rPr sz="1000">
                 <a:solidFill>
                   <a:srgbClr val="FFFFFF"/>
                 </a:solidFill>
                 <a:latin typeface="Arial"/>
               </a:rPr>
-              <a:t>Site selection, household recruitment, hosting agreements, contractor network management, installation QA, fleet reporting, regulatory compliance</a:t>
+              <a:t>Site selection, household recruitment, hosting agreements, contractor network, install QA, fleet reporting, compliance</a:t>
             </a:r>
           </a:p>
         </p:txBody>
@@ -4252,7 +4306,7 @@
         </p:nvSpPr>
         <p:spPr>
           <a:xfrm>
-            <a:off x="3794760" y="2194560"/>
+            <a:off x="3794760" y="1965960"/>
             <a:ext cx="320040" cy="457200"/>
           </a:xfrm>
           <a:prstGeom prst="rect">
@@ -4268,7 +4322,7 @@
           <a:p>
             <a:pPr algn="ctr"/>
             <a:r>
-              <a:rPr sz="2400" b="1">
+              <a:rPr sz="2200" b="1">
                 <a:solidFill>
                   <a:srgbClr val="1B2A5E"/>
                 </a:solidFill>
@@ -4286,7 +4340,7 @@
         </p:nvSpPr>
         <p:spPr>
           <a:xfrm>
-            <a:off x="7452360" y="2194560"/>
+            <a:off x="7452360" y="1965960"/>
             <a:ext cx="320040" cy="457200"/>
           </a:xfrm>
           <a:prstGeom prst="rect">
@@ -4302,7 +4356,7 @@
           <a:p>
             <a:pPr algn="ctr"/>
             <a:r>
-              <a:rPr sz="2400" b="1">
+              <a:rPr sz="2200" b="1">
                 <a:solidFill>
                   <a:srgbClr val="1B2A5E"/>
                 </a:solidFill>
@@ -4314,14 +4368,68 @@
       </p:sp>
       <p:sp>
         <p:nvSpPr>
-          <p:cNvPr id="9" name="TextBox 8"/>
+          <p:cNvPr id="9" name="Rectangle 8"/>
+          <p:cNvSpPr/>
+          <p:nvPr/>
+        </p:nvSpPr>
+        <p:spPr>
+          <a:xfrm>
+            <a:off x="457200" y="3063240"/>
+            <a:ext cx="11247120" cy="594360"/>
+          </a:xfrm>
+          <a:prstGeom prst="rect">
+            <a:avLst/>
+          </a:prstGeom>
+          <a:solidFill>
+            <a:srgbClr val="FFF6E8"/>
+          </a:solidFill>
+          <a:ln w="12700">
+            <a:solidFill>
+              <a:srgbClr val="E87B22"/>
+            </a:solidFill>
+          </a:ln>
+        </p:spPr>
+        <p:style>
+          <a:lnRef idx="1">
+            <a:schemeClr val="accent1"/>
+          </a:lnRef>
+          <a:fillRef idx="3">
+            <a:schemeClr val="accent1"/>
+          </a:fillRef>
+          <a:effectRef idx="2">
+            <a:schemeClr val="accent1"/>
+          </a:effectRef>
+          <a:fontRef idx="minor">
+            <a:schemeClr val="lt1"/>
+          </a:fontRef>
+        </p:style>
+        <p:txBody>
+          <a:bodyPr rtlCol="0" anchor="ctr" wrap="square" lIns="137160" tIns="91440"/>
+          <a:lstStyle/>
+          <a:p>
+            <a:pPr algn="ctr"/>
+            <a:r>
+              <a:rPr sz="1100" i="1">
+                <a:solidFill>
+                  <a:srgbClr val="664E1A"/>
+                </a:solidFill>
+                <a:latin typeface="Arial"/>
+              </a:rPr>
+              <a:t>Who pays: the utility recovers its investment from ALL ratepayers via rate base (standard cost-of-service regulation) -- not a special charge to the hosting household. The household's "payment" for hosting is free backup power and lower bills. This is NOT a Power Purchase Agreement -- the utility owns the asset directly, it does not buy output from a third-party owner.</a:t>
+            </a:r>
+          </a:p>
+        </p:txBody>
+      </p:sp>
+      <p:sp>
+        <p:nvSpPr>
+          <p:cNvPr id="10" name="TextBox 9"/>
           <p:cNvSpPr txBox="1"/>
           <p:nvPr/>
         </p:nvSpPr>
         <p:spPr>
           <a:xfrm>
-            <a:off x="457200" y="3429000"/>
-            <a:ext cx="5486400" cy="365760"/>
+            <a:off x="457200" y="3794760"/>
+            <a:ext cx="5486400" cy="320040"/>
           </a:xfrm>
           <a:prstGeom prst="rect">
             <a:avLst/>
@@ -4341,21 +4449,21 @@
                 </a:solidFill>
                 <a:latin typeface="Arial"/>
               </a:rPr>
-              <a:t>Revenue Model</a:t>
-            </a:r>
-          </a:p>
-        </p:txBody>
-      </p:sp>
-      <p:sp>
-        <p:nvSpPr>
-          <p:cNvPr id="10" name="TextBox 9"/>
+              <a:t>How APTIM Gets Paid</a:t>
+            </a:r>
+          </a:p>
+        </p:txBody>
+      </p:sp>
+      <p:sp>
+        <p:nvSpPr>
+          <p:cNvPr id="11" name="TextBox 10"/>
           <p:cNvSpPr txBox="1"/>
           <p:nvPr/>
         </p:nvSpPr>
         <p:spPr>
           <a:xfrm>
-            <a:off x="457200" y="3794760"/>
-            <a:ext cx="5486400" cy="2011680"/>
+            <a:off x="457200" y="4160520"/>
+            <a:ext cx="5486400" cy="1645920"/>
           </a:xfrm>
           <a:prstGeom prst="rect">
             <a:avLst/>
@@ -4380,7 +4488,7 @@
                 </a:solidFill>
                 <a:latin typeface="Arial"/>
               </a:rPr>
-              <a:t>Utility earns: </a:t>
+              <a:t>Base structure: </a:t>
             </a:r>
             <a:r>
               <a:rPr sz="1200">
@@ -4389,7 +4497,7 @@
                 </a:solidFill>
                 <a:latin typeface="Arial"/>
               </a:rPr>
-              <a:t>Regulated rate-of-return on rate-based capital, plus avoided peaker/T&amp;D deferral value</a:t>
+              <a:t>Level-of-effort / cost-plus fee -- consistent with APTIM's existing Focus on Energy model</a:t>
             </a:r>
           </a:p>
           <a:p>
@@ -4405,7 +4513,7 @@
                 </a:solidFill>
                 <a:latin typeface="Arial"/>
               </a:rPr>
-              <a:t>APTIM earns: </a:t>
+              <a:t>Differentiator: </a:t>
             </a:r>
             <a:r>
               <a:rPr sz="1200">
@@ -4414,7 +4522,7 @@
                 </a:solidFill>
                 <a:latin typeface="Arial"/>
               </a:rPr>
-              <a:t>Level-of-effort administration fee — insulated from hardware price swings</a:t>
+              <a:t>Performance incentive tied to fleet uptime/dispatch reliability -- aligns APTIM's incentive with utility outcomes</a:t>
             </a:r>
           </a:p>
           <a:p>
@@ -4430,7 +4538,7 @@
                 </a:solidFill>
                 <a:latin typeface="Arial"/>
               </a:rPr>
-              <a:t>Household earns: </a:t>
+              <a:t>Exact terms: </a:t>
             </a:r>
             <a:r>
               <a:rPr sz="1200">
@@ -4439,46 +4547,21 @@
                 </a:solidFill>
                 <a:latin typeface="Arial"/>
               </a:rPr>
-              <a:t>Free backup power + lower bills; zero cost, zero maintenance</a:t>
-            </a:r>
-          </a:p>
-          <a:p>
-            <a:pPr>
-              <a:spcAft>
-                <a:spcPts val="800"/>
-              </a:spcAft>
-            </a:pPr>
-            <a:r>
-              <a:rPr b="1" sz="1200">
-                <a:solidFill>
-                  <a:srgbClr val="1B2A5E"/>
-                </a:solidFill>
-                <a:latin typeface="Arial"/>
-              </a:rPr>
-              <a:t>O&amp;M funded by: </a:t>
-            </a:r>
-            <a:r>
-              <a:rPr sz="1200">
-                <a:solidFill>
-                  <a:srgbClr val="333333"/>
-                </a:solidFill>
-                <a:latin typeface="Arial"/>
-              </a:rPr>
-              <a:t>Dispatch value ($500-$1,500/kW avoided capacity cost) — the asset funds its own upkeep</a:t>
-            </a:r>
-          </a:p>
-        </p:txBody>
-      </p:sp>
-      <p:sp>
-        <p:nvSpPr>
-          <p:cNvPr id="11" name="TextBox 10"/>
+              <a:t>To be negotiated through the RFP process -- not fixed at this stage</a:t>
+            </a:r>
+          </a:p>
+        </p:txBody>
+      </p:sp>
+      <p:sp>
+        <p:nvSpPr>
+          <p:cNvPr id="12" name="TextBox 11"/>
           <p:cNvSpPr txBox="1"/>
           <p:nvPr/>
         </p:nvSpPr>
         <p:spPr>
           <a:xfrm>
-            <a:off x="6217920" y="3429000"/>
-            <a:ext cx="5486400" cy="365760"/>
+            <a:off x="6217920" y="3794760"/>
+            <a:ext cx="5486400" cy="320040"/>
           </a:xfrm>
           <a:prstGeom prst="rect">
             <a:avLst/>
@@ -4505,14 +4588,14 @@
       </p:sp>
       <p:sp>
         <p:nvSpPr>
-          <p:cNvPr id="12" name="TextBox 11"/>
+          <p:cNvPr id="13" name="TextBox 12"/>
           <p:cNvSpPr txBox="1"/>
           <p:nvPr/>
         </p:nvSpPr>
         <p:spPr>
           <a:xfrm>
-            <a:off x="6217920" y="3794760"/>
-            <a:ext cx="5486400" cy="2011680"/>
+            <a:off x="6217920" y="4160520"/>
+            <a:ext cx="5486400" cy="1645920"/>
           </a:xfrm>
           <a:prstGeom prst="rect">
             <a:avLst/>
@@ -4546,7 +4629,7 @@
                 </a:solidFill>
                 <a:latin typeface="Arial"/>
               </a:rPr>
-              <a:t>Cheaper peak capacity than a new peaker plant; grows rate base; meets Michigan's statutory storage mandate</a:t>
+              <a:t>Meets statutory storage mandate; cheaper than a new peaker plant; grows rate base</a:t>
             </a:r>
           </a:p>
           <a:p>
@@ -4571,7 +4654,7 @@
                 </a:solidFill>
                 <a:latin typeface="Arial"/>
               </a:rPr>
-              <a:t>Backup power during a storm-prone state's worst-in-nation outages — at zero cost</a:t>
+              <a:t>Backup power in the state with the worst outages in the nation, at zero cost</a:t>
             </a:r>
           </a:p>
           <a:p>
@@ -4596,14 +4679,48 @@
                 </a:solidFill>
                 <a:latin typeface="Arial"/>
               </a:rPr>
-              <a:t>Resilience delivered to vulnerable communities without a new tax or appropriation</a:t>
-            </a:r>
-          </a:p>
-        </p:txBody>
-      </p:sp>
-      <p:sp>
-        <p:nvSpPr>
-          <p:cNvPr id="13" name="TextBox 12"/>
+              <a:t>Resilience delivered without a new tax or appropriation</a:t>
+            </a:r>
+          </a:p>
+        </p:txBody>
+      </p:sp>
+      <p:sp>
+        <p:nvSpPr>
+          <p:cNvPr id="14" name="TextBox 13"/>
+          <p:cNvSpPr txBox="1"/>
+          <p:nvPr/>
+        </p:nvSpPr>
+        <p:spPr>
+          <a:xfrm>
+            <a:off x="457200" y="5989320"/>
+            <a:ext cx="11247120" cy="457200"/>
+          </a:xfrm>
+          <a:prstGeom prst="rect">
+            <a:avLst/>
+          </a:prstGeom>
+          <a:noFill/>
+        </p:spPr>
+        <p:txBody>
+          <a:bodyPr wrap="none">
+            <a:spAutoFit/>
+          </a:bodyPr>
+          <a:lstStyle/>
+          <a:p>
+            <a:r>
+              <a:rPr sz="1000" i="1">
+                <a:solidFill>
+                  <a:srgbClr val="777777"/>
+                </a:solidFill>
+                <a:latin typeface="Arial"/>
+              </a:rPr>
+              <a:t>Open items for RFP-stage negotiation: exact fee %, named installer network, interconnection process for utility-owned residential batteries (flagged as a regulatory question to work through with MPSC, not assumed).</a:t>
+            </a:r>
+          </a:p>
+        </p:txBody>
+      </p:sp>
+      <p:sp>
+        <p:nvSpPr>
+          <p:cNvPr id="15" name="TextBox 14"/>
           <p:cNvSpPr txBox="1"/>
           <p:nvPr/>
         </p:nvSpPr>
@@ -4637,7 +4754,7 @@
       </p:sp>
       <p:sp>
         <p:nvSpPr>
-          <p:cNvPr id="14" name="TextBox 13"/>
+          <p:cNvPr id="16" name="TextBox 15"/>
           <p:cNvSpPr txBox="1"/>
           <p:nvPr/>
         </p:nvSpPr>

</xml_diff>

<commit_message>
Refocus slides on APTIM implementation approach rather than state comparison
Co-Authored-By: Claude Sonnet 5 <noreply@anthropic.com>
Claude-Session: https://claude.ai/code/session_018Bg71BX6us34ZYpqiy24Sa
</commit_message>
<xml_diff>
--- a/STRIVE_Capstone_Christian_Slides.pptx
+++ b/STRIVE_Capstone_Christian_Slides.pptx
@@ -3118,7 +3118,7 @@
                 </a:solidFill>
                 <a:latin typeface="Arial"/>
               </a:rPr>
-              <a:t>Prioritization Framework: Selecting Our Pilot State</a:t>
+              <a:t>Implementation Approach: How APTIM Runs This Program</a:t>
             </a:r>
           </a:p>
         </p:txBody>
@@ -3146,555 +3146,36 @@
           <a:lstStyle/>
           <a:p>
             <a:r>
-              <a:rPr sz="1400" i="1">
+              <a:rPr sz="1300" i="1">
                 <a:solidFill>
                   <a:srgbClr val="777777"/>
                 </a:solidFill>
                 <a:latin typeface="Arial"/>
               </a:rPr>
-              <a:t>Ranked on cost, ease of implementation, timeframe, and impact</a:t>
-            </a:r>
-          </a:p>
-        </p:txBody>
-      </p:sp>
-      <p:graphicFrame>
-        <p:nvGraphicFramePr>
-          <p:cNvPr id="4" name="Table 3"/>
-          <p:cNvGraphicFramePr>
-            <a:graphicFrameLocks noGrp="1"/>
-          </p:cNvGraphicFramePr>
-          <p:nvPr/>
-        </p:nvGraphicFramePr>
-        <p:xfrm>
-          <a:off x="457200" y="1371600"/>
-          <a:ext cx="11247120" cy="1828800"/>
-        </p:xfrm>
-        <a:graphic>
-          <a:graphicData uri="http://schemas.openxmlformats.org/drawingml/2006/table">
-            <a:tbl>
-              <a:tblPr firstRow="1" bandRow="1">
-                <a:tableStyleId>{5C22544A-7EE6-4342-B048-85BDC9FD1C3A}</a:tableStyleId>
-              </a:tblPr>
-              <a:tblGrid>
-                <a:gridCol w="1554480"/>
-                <a:gridCol w="2377440"/>
-                <a:gridCol w="2651760"/>
-                <a:gridCol w="3291840"/>
-                <a:gridCol w="1371600"/>
-              </a:tblGrid>
-              <a:tr h="457200">
-                <a:tc>
-                  <a:txBody>
-                    <a:bodyPr/>
-                    <a:lstStyle/>
-                    <a:p>
-                      <a:pPr>
-                        <a:defRPr sz="1100" b="1">
-                          <a:solidFill>
-                            <a:srgbClr val="FFFFFF"/>
-                          </a:solidFill>
-                          <a:latin typeface="Arial"/>
-                        </a:defRPr>
-                      </a:pPr>
-                      <a:r>
-                        <a:t>State</a:t>
-                      </a:r>
-                    </a:p>
-                  </a:txBody>
-                  <a:tcPr>
-                    <a:solidFill>
-                      <a:srgbClr val="1B2A5E"/>
-                    </a:solidFill>
-                  </a:tcPr>
-                </a:tc>
-                <a:tc>
-                  <a:txBody>
-                    <a:bodyPr/>
-                    <a:lstStyle/>
-                    <a:p>
-                      <a:pPr>
-                        <a:defRPr sz="1100" b="1">
-                          <a:solidFill>
-                            <a:srgbClr val="FFFFFF"/>
-                          </a:solidFill>
-                          <a:latin typeface="Arial"/>
-                        </a:defRPr>
-                      </a:pPr>
-                      <a:r>
-                        <a:t>APTIM Relationship</a:t>
-                      </a:r>
-                    </a:p>
-                  </a:txBody>
-                  <a:tcPr>
-                    <a:solidFill>
-                      <a:srgbClr val="1B2A5E"/>
-                    </a:solidFill>
-                  </a:tcPr>
-                </a:tc>
-                <a:tc>
-                  <a:txBody>
-                    <a:bodyPr/>
-                    <a:lstStyle/>
-                    <a:p>
-                      <a:pPr>
-                        <a:defRPr sz="1100" b="1">
-                          <a:solidFill>
-                            <a:srgbClr val="FFFFFF"/>
-                          </a:solidFill>
-                          <a:latin typeface="Arial"/>
-                        </a:defRPr>
-                      </a:pPr>
-                      <a:r>
-                        <a:t>Ease of Entry</a:t>
-                      </a:r>
-                    </a:p>
-                  </a:txBody>
-                  <a:tcPr>
-                    <a:solidFill>
-                      <a:srgbClr val="1B2A5E"/>
-                    </a:solidFill>
-                  </a:tcPr>
-                </a:tc>
-                <a:tc>
-                  <a:txBody>
-                    <a:bodyPr/>
-                    <a:lstStyle/>
-                    <a:p>
-                      <a:pPr>
-                        <a:defRPr sz="1100" b="1">
-                          <a:solidFill>
-                            <a:srgbClr val="FFFFFF"/>
-                          </a:solidFill>
-                          <a:latin typeface="Arial"/>
-                        </a:defRPr>
-                      </a:pPr>
-                      <a:r>
-                        <a:t>Impact</a:t>
-                      </a:r>
-                    </a:p>
-                  </a:txBody>
-                  <a:tcPr>
-                    <a:solidFill>
-                      <a:srgbClr val="1B2A5E"/>
-                    </a:solidFill>
-                  </a:tcPr>
-                </a:tc>
-                <a:tc>
-                  <a:txBody>
-                    <a:bodyPr/>
-                    <a:lstStyle/>
-                    <a:p>
-                      <a:pPr>
-                        <a:defRPr sz="1100" b="1">
-                          <a:solidFill>
-                            <a:srgbClr val="FFFFFF"/>
-                          </a:solidFill>
-                          <a:latin typeface="Arial"/>
-                        </a:defRPr>
-                      </a:pPr>
-                      <a:r>
-                        <a:t>Role</a:t>
-                      </a:r>
-                    </a:p>
-                  </a:txBody>
-                  <a:tcPr>
-                    <a:solidFill>
-                      <a:srgbClr val="1B2A5E"/>
-                    </a:solidFill>
-                  </a:tcPr>
-                </a:tc>
-              </a:tr>
-              <a:tr h="457200">
-                <a:tc>
-                  <a:txBody>
-                    <a:bodyPr/>
-                    <a:lstStyle/>
-                    <a:p>
-                      <a:pPr>
-                        <a:defRPr sz="1100">
-                          <a:solidFill>
-                            <a:srgbClr val="333333"/>
-                          </a:solidFill>
-                          <a:latin typeface="Arial"/>
-                        </a:defRPr>
-                      </a:pPr>
-                      <a:r>
-                        <a:t>California</a:t>
-                      </a:r>
-                    </a:p>
-                  </a:txBody>
-                  <a:tcPr>
-                    <a:solidFill>
-                      <a:srgbClr val="F2F4F8"/>
-                    </a:solidFill>
-                  </a:tcPr>
-                </a:tc>
-                <a:tc>
-                  <a:txBody>
-                    <a:bodyPr/>
-                    <a:lstStyle/>
-                    <a:p>
-                      <a:pPr>
-                        <a:defRPr sz="1100">
-                          <a:solidFill>
-                            <a:srgbClr val="333333"/>
-                          </a:solidFill>
-                          <a:latin typeface="Arial"/>
-                        </a:defRPr>
-                      </a:pPr>
-                      <a:r>
-                        <a:t>None — reference market</a:t>
-                      </a:r>
-                    </a:p>
-                  </a:txBody>
-                  <a:tcPr>
-                    <a:solidFill>
-                      <a:srgbClr val="F2F4F8"/>
-                    </a:solidFill>
-                  </a:tcPr>
-                </a:tc>
-                <a:tc>
-                  <a:txBody>
-                    <a:bodyPr/>
-                    <a:lstStyle/>
-                    <a:p>
-                      <a:pPr>
-                        <a:defRPr sz="1100">
-                          <a:solidFill>
-                            <a:srgbClr val="333333"/>
-                          </a:solidFill>
-                          <a:latin typeface="Arial"/>
-                        </a:defRPr>
-                      </a:pPr>
-                      <a:r>
-                        <a:t>High — mature, proven model</a:t>
-                      </a:r>
-                    </a:p>
-                  </a:txBody>
-                  <a:tcPr>
-                    <a:solidFill>
-                      <a:srgbClr val="F2F4F8"/>
-                    </a:solidFill>
-                  </a:tcPr>
-                </a:tc>
-                <a:tc>
-                  <a:txBody>
-                    <a:bodyPr/>
-                    <a:lstStyle/>
-                    <a:p>
-                      <a:pPr>
-                        <a:defRPr sz="1100">
-                          <a:solidFill>
-                            <a:srgbClr val="333333"/>
-                          </a:solidFill>
-                          <a:latin typeface="Arial"/>
-                        </a:defRPr>
-                      </a:pPr>
-                      <a:r>
-                        <a:t>Validates the concept works</a:t>
-                      </a:r>
-                    </a:p>
-                  </a:txBody>
-                  <a:tcPr>
-                    <a:solidFill>
-                      <a:srgbClr val="F2F4F8"/>
-                    </a:solidFill>
-                  </a:tcPr>
-                </a:tc>
-                <a:tc>
-                  <a:txBody>
-                    <a:bodyPr/>
-                    <a:lstStyle/>
-                    <a:p>
-                      <a:pPr>
-                        <a:defRPr sz="1100">
-                          <a:solidFill>
-                            <a:srgbClr val="333333"/>
-                          </a:solidFill>
-                          <a:latin typeface="Arial"/>
-                        </a:defRPr>
-                      </a:pPr>
-                      <a:r>
-                        <a:t>Proof It Works</a:t>
-                      </a:r>
-                    </a:p>
-                  </a:txBody>
-                  <a:tcPr>
-                    <a:solidFill>
-                      <a:srgbClr val="F2F4F8"/>
-                    </a:solidFill>
-                  </a:tcPr>
-                </a:tc>
-              </a:tr>
-              <a:tr h="457200">
-                <a:tc>
-                  <a:txBody>
-                    <a:bodyPr/>
-                    <a:lstStyle/>
-                    <a:p>
-                      <a:pPr>
-                        <a:defRPr sz="1100">
-                          <a:solidFill>
-                            <a:srgbClr val="333333"/>
-                          </a:solidFill>
-                          <a:latin typeface="Arial"/>
-                        </a:defRPr>
-                      </a:pPr>
-                      <a:r>
-                        <a:t>North Carolina</a:t>
-                      </a:r>
-                    </a:p>
-                  </a:txBody>
-                  <a:tcPr>
-                    <a:solidFill>
-                      <a:srgbClr val="FFFFFF"/>
-                    </a:solidFill>
-                  </a:tcPr>
-                </a:tc>
-                <a:tc>
-                  <a:txBody>
-                    <a:bodyPr/>
-                    <a:lstStyle/>
-                    <a:p>
-                      <a:pPr>
-                        <a:defRPr sz="1100">
-                          <a:solidFill>
-                            <a:srgbClr val="333333"/>
-                          </a:solidFill>
-                          <a:latin typeface="Arial"/>
-                        </a:defRPr>
-                      </a:pPr>
-                      <a:r>
-                        <a:t>None — reference market</a:t>
-                      </a:r>
-                    </a:p>
-                  </a:txBody>
-                  <a:tcPr>
-                    <a:solidFill>
-                      <a:srgbClr val="FFFFFF"/>
-                    </a:solidFill>
-                  </a:tcPr>
-                </a:tc>
-                <a:tc>
-                  <a:txBody>
-                    <a:bodyPr/>
-                    <a:lstStyle/>
-                    <a:p>
-                      <a:pPr>
-                        <a:defRPr sz="1100">
-                          <a:solidFill>
-                            <a:srgbClr val="333333"/>
-                          </a:solidFill>
-                          <a:latin typeface="Arial"/>
-                        </a:defRPr>
-                      </a:pPr>
-                      <a:r>
-                        <a:t>Medium — Duke moving this direction</a:t>
-                      </a:r>
-                    </a:p>
-                  </a:txBody>
-                  <a:tcPr>
-                    <a:solidFill>
-                      <a:srgbClr val="FFFFFF"/>
-                    </a:solidFill>
-                  </a:tcPr>
-                </a:tc>
-                <a:tc>
-                  <a:txBody>
-                    <a:bodyPr/>
-                    <a:lstStyle/>
-                    <a:p>
-                      <a:pPr>
-                        <a:defRPr sz="1100">
-                          <a:solidFill>
-                            <a:srgbClr val="333333"/>
-                          </a:solidFill>
-                          <a:latin typeface="Arial"/>
-                        </a:defRPr>
-                      </a:pPr>
-                      <a:r>
-                        <a:t>PowerPair fully subscribed/waitlisted — proves demand</a:t>
-                      </a:r>
-                    </a:p>
-                  </a:txBody>
-                  <a:tcPr>
-                    <a:solidFill>
-                      <a:srgbClr val="FFFFFF"/>
-                    </a:solidFill>
-                  </a:tcPr>
-                </a:tc>
-                <a:tc>
-                  <a:txBody>
-                    <a:bodyPr/>
-                    <a:lstStyle/>
-                    <a:p>
-                      <a:pPr>
-                        <a:defRPr sz="1100">
-                          <a:solidFill>
-                            <a:srgbClr val="333333"/>
-                          </a:solidFill>
-                          <a:latin typeface="Arial"/>
-                        </a:defRPr>
-                      </a:pPr>
-                      <a:r>
-                        <a:t>Proof Demand Exists</a:t>
-                      </a:r>
-                    </a:p>
-                  </a:txBody>
-                  <a:tcPr>
-                    <a:solidFill>
-                      <a:srgbClr val="FFFFFF"/>
-                    </a:solidFill>
-                  </a:tcPr>
-                </a:tc>
-              </a:tr>
-              <a:tr h="457200">
-                <a:tc>
-                  <a:txBody>
-                    <a:bodyPr/>
-                    <a:lstStyle/>
-                    <a:p>
-                      <a:pPr>
-                        <a:defRPr sz="1100">
-                          <a:solidFill>
-                            <a:srgbClr val="333333"/>
-                          </a:solidFill>
-                          <a:latin typeface="Arial"/>
-                        </a:defRPr>
-                      </a:pPr>
-                      <a:r>
-                        <a:t>Michigan</a:t>
-                      </a:r>
-                    </a:p>
-                  </a:txBody>
-                  <a:tcPr>
-                    <a:solidFill>
-                      <a:srgbClr val="F2F4F8"/>
-                    </a:solidFill>
-                  </a:tcPr>
-                </a:tc>
-                <a:tc>
-                  <a:txBody>
-                    <a:bodyPr/>
-                    <a:lstStyle/>
-                    <a:p>
-                      <a:pPr>
-                        <a:defRPr sz="1100">
-                          <a:solidFill>
-                            <a:srgbClr val="333333"/>
-                          </a:solidFill>
-                          <a:latin typeface="Arial"/>
-                        </a:defRPr>
-                      </a:pPr>
-                      <a:r>
-                        <a:t>None confirmed — market-entry pitch</a:t>
-                      </a:r>
-                    </a:p>
-                  </a:txBody>
-                  <a:tcPr>
-                    <a:solidFill>
-                      <a:srgbClr val="F2F4F8"/>
-                    </a:solidFill>
-                  </a:tcPr>
-                </a:tc>
-                <a:tc>
-                  <a:txBody>
-                    <a:bodyPr/>
-                    <a:lstStyle/>
-                    <a:p>
-                      <a:pPr>
-                        <a:defRPr sz="1100">
-                          <a:solidFill>
-                            <a:srgbClr val="333333"/>
-                          </a:solidFill>
-                          <a:latin typeface="Arial"/>
-                        </a:defRPr>
-                      </a:pPr>
-                      <a:r>
-                        <a:t>High — vertically integrated utility, statutory mandate</a:t>
-                      </a:r>
-                    </a:p>
-                  </a:txBody>
-                  <a:tcPr>
-                    <a:solidFill>
-                      <a:srgbClr val="F2F4F8"/>
-                    </a:solidFill>
-                  </a:tcPr>
-                </a:tc>
-                <a:tc>
-                  <a:txBody>
-                    <a:bodyPr/>
-                    <a:lstStyle/>
-                    <a:p>
-                      <a:pPr>
-                        <a:defRPr sz="1100">
-                          <a:solidFill>
-                            <a:srgbClr val="333333"/>
-                          </a:solidFill>
-                          <a:latin typeface="Arial"/>
-                        </a:defRPr>
-                      </a:pPr>
-                      <a:r>
-                        <a:t>Worst outages in nation + 2,500 MW storage mandate (2029 deadline)</a:t>
-                      </a:r>
-                    </a:p>
-                  </a:txBody>
-                  <a:tcPr>
-                    <a:solidFill>
-                      <a:srgbClr val="F2F4F8"/>
-                    </a:solidFill>
-                  </a:tcPr>
-                </a:tc>
-                <a:tc>
-                  <a:txBody>
-                    <a:bodyPr/>
-                    <a:lstStyle/>
-                    <a:p>
-                      <a:pPr>
-                        <a:defRPr sz="1100">
-                          <a:solidFill>
-                            <a:srgbClr val="333333"/>
-                          </a:solidFill>
-                          <a:latin typeface="Arial"/>
-                        </a:defRPr>
-                      </a:pPr>
-                      <a:r>
-                        <a:t>RECOMMENDED PILOT</a:t>
-                      </a:r>
-                    </a:p>
-                  </a:txBody>
-                  <a:tcPr>
-                    <a:solidFill>
-                      <a:srgbClr val="F2F4F8"/>
-                    </a:solidFill>
-                  </a:tcPr>
-                </a:tc>
-              </a:tr>
-            </a:tbl>
-          </a:graphicData>
-        </a:graphic>
-      </p:graphicFrame>
-      <p:sp>
-        <p:nvSpPr>
-          <p:cNvPr id="5" name="Rectangle 4"/>
+              <a:t>Four phases, from contract award to ongoing fleet operations — the same lifecycle APTIM already runs for Focus on Energy</a:t>
+            </a:r>
+          </a:p>
+        </p:txBody>
+      </p:sp>
+      <p:sp>
+        <p:nvSpPr>
+          <p:cNvPr id="4" name="Rectangle 3"/>
           <p:cNvSpPr/>
           <p:nvPr/>
         </p:nvSpPr>
         <p:spPr>
           <a:xfrm>
-            <a:off x="457200" y="3337560"/>
-            <a:ext cx="11247120" cy="502920"/>
+            <a:off x="457200" y="1508760"/>
+            <a:ext cx="2606040" cy="2606040"/>
           </a:xfrm>
           <a:prstGeom prst="rect">
             <a:avLst/>
           </a:prstGeom>
           <a:solidFill>
-            <a:srgbClr val="FFF6E8"/>
+            <a:srgbClr val="1B2A5E"/>
           </a:solidFill>
-          <a:ln w="12700">
-            <a:solidFill>
-              <a:srgbClr val="E87B22"/>
-            </a:solidFill>
+          <a:ln>
+            <a:noFill/>
           </a:ln>
         </p:spPr>
         <p:style>
@@ -3712,43 +3193,66 @@
           </a:fontRef>
         </p:style>
         <p:txBody>
-          <a:bodyPr rtlCol="0" anchor="ctr" wrap="square" lIns="137160" tIns="91440"/>
+          <a:bodyPr rtlCol="0" anchor="ctr" wrap="square" lIns="137160" tIns="137160" rIns="137160"/>
           <a:lstStyle/>
           <a:p>
             <a:pPr algn="ctr"/>
             <a:r>
-              <a:rPr sz="1100" i="1">
-                <a:solidFill>
-                  <a:srgbClr val="664E1A"/>
-                </a:solidFill>
-                <a:latin typeface="Arial"/>
-              </a:rPr>
-              <a:t>Note: APTIM has no confirmed existing contract in any of these three states for this exact program. This is a market-entry pitch built on regulatory/economic fit, not incumbency — unlike our Wisconsin and Louisiana relationships, held as expansion options.</a:t>
-            </a:r>
-          </a:p>
-        </p:txBody>
-      </p:sp>
-      <p:sp>
-        <p:nvSpPr>
-          <p:cNvPr id="6" name="Rectangle 5"/>
+              <a:rPr b="1" sz="1500">
+                <a:solidFill>
+                  <a:srgbClr val="FFFFFF"/>
+                </a:solidFill>
+                <a:latin typeface="Arial"/>
+              </a:rPr>
+              <a:t>Phase 1
+Win &amp; Design</a:t>
+            </a:r>
+          </a:p>
+          <a:p>
+            <a:pPr algn="ctr"/>
+            <a:r>
+              <a:rPr sz="1100">
+                <a:solidFill>
+                  <a:srgbClr val="FFFFFF"/>
+                </a:solidFill>
+                <a:latin typeface="Arial"/>
+              </a:rPr>
+              <a:t>Respond to utility RFP; design program rules, eligibility criteria, and rate-case support materials</a:t>
+            </a:r>
+          </a:p>
+          <a:p>
+            <a:pPr algn="ctr"/>
+            <a:r>
+              <a:rPr sz="1100" b="1" i="1">
+                <a:solidFill>
+                  <a:srgbClr val="FFFFFF"/>
+                </a:solidFill>
+                <a:latin typeface="Arial"/>
+              </a:rPr>
+              <a:t>0-6 mo</a:t>
+            </a:r>
+          </a:p>
+        </p:txBody>
+      </p:sp>
+      <p:sp>
+        <p:nvSpPr>
+          <p:cNvPr id="5" name="Rectangle 4"/>
           <p:cNvSpPr/>
           <p:nvPr/>
         </p:nvSpPr>
         <p:spPr>
           <a:xfrm>
-            <a:off x="457200" y="3977639"/>
-            <a:ext cx="11247120" cy="1965960"/>
+            <a:off x="3200400" y="1508760"/>
+            <a:ext cx="2606040" cy="2606040"/>
           </a:xfrm>
           <a:prstGeom prst="rect">
             <a:avLst/>
           </a:prstGeom>
           <a:solidFill>
-            <a:srgbClr val="F2F4F8"/>
+            <a:srgbClr val="E87B22"/>
           </a:solidFill>
-          <a:ln w="19050">
-            <a:solidFill>
-              <a:srgbClr val="E87B22"/>
-            </a:solidFill>
+          <a:ln>
+            <a:noFill/>
           </a:ln>
         </p:spPr>
         <p:style>
@@ -3766,132 +3270,211 @@
           </a:fontRef>
         </p:style>
         <p:txBody>
-          <a:bodyPr rtlCol="0" anchor="ctr" wrap="square" lIns="182880" tIns="137160"/>
+          <a:bodyPr rtlCol="0" anchor="ctr" wrap="square" lIns="137160" tIns="137160" rIns="137160"/>
           <a:lstStyle/>
           <a:p>
             <a:pPr algn="ctr"/>
             <a:r>
               <a:rPr b="1" sz="1500">
                 <a:solidFill>
-                  <a:srgbClr val="1B2A5E"/>
-                </a:solidFill>
-                <a:latin typeface="Arial"/>
-              </a:rPr>
-              <a:t>Why Michigan — Sourced Evidence</a:t>
-            </a:r>
-          </a:p>
-          <a:p>
-            <a:pPr>
-              <a:spcAft>
-                <a:spcPts val="300"/>
-              </a:spcAft>
-            </a:pPr>
-            <a:r>
-              <a:rPr b="1" sz="1200">
-                <a:solidFill>
-                  <a:srgbClr val="E87B22"/>
-                </a:solidFill>
-                <a:latin typeface="Arial"/>
-              </a:rPr>
-              <a:t>Reliability: </a:t>
-            </a:r>
-            <a:r>
-              <a:rPr sz="1200">
-                <a:solidFill>
-                  <a:srgbClr val="333333"/>
-                </a:solidFill>
-                <a:latin typeface="Arial"/>
-              </a:rPr>
-              <a:t>50th of 51 states in outage duration — and outages are distribution-level, exactly what a home battery covers.</a:t>
-            </a:r>
-          </a:p>
-          <a:p>
-            <a:pPr>
-              <a:spcAft>
-                <a:spcPts val="300"/>
-              </a:spcAft>
-            </a:pPr>
-            <a:r>
-              <a:rPr b="1" sz="1200">
-                <a:solidFill>
-                  <a:srgbClr val="E87B22"/>
-                </a:solidFill>
-                <a:latin typeface="Arial"/>
-              </a:rPr>
-              <a:t>Policy hook: </a:t>
-            </a:r>
-            <a:r>
-              <a:rPr sz="1200">
-                <a:solidFill>
-                  <a:srgbClr val="333333"/>
-                </a:solidFill>
-                <a:latin typeface="Arial"/>
-              </a:rPr>
-              <a:t>PA 235 (2023) mandates 2,500 MW of storage; MPSC Case No. U-21571 sets compliance petitions due Dec 31, 2029.</a:t>
-            </a:r>
-          </a:p>
-          <a:p>
-            <a:pPr>
-              <a:spcAft>
-                <a:spcPts val="300"/>
-              </a:spcAft>
-            </a:pPr>
-            <a:r>
-              <a:rPr b="1" sz="1200">
-                <a:solidFill>
-                  <a:srgbClr val="E87B22"/>
-                </a:solidFill>
-                <a:latin typeface="Arial"/>
-              </a:rPr>
-              <a:t>Utility need: </a:t>
-            </a:r>
-            <a:r>
-              <a:rPr sz="1200">
-                <a:solidFill>
-                  <a:srgbClr val="333333"/>
-                </a:solidFill>
-                <a:latin typeface="Arial"/>
-              </a:rPr>
-              <a:t>DTE IRP (Case U-21193) cites 850+ MW storage need; Consumers IRP (Case U-21090) targets 75 MW by 2027, 550 MW by 2040.</a:t>
-            </a:r>
-          </a:p>
-          <a:p>
-            <a:pPr>
-              <a:spcAft>
-                <a:spcPts val="300"/>
-              </a:spcAft>
-            </a:pPr>
-            <a:r>
-              <a:rPr b="1" sz="1200">
-                <a:solidFill>
-                  <a:srgbClr val="E87B22"/>
-                </a:solidFill>
-                <a:latin typeface="Arial"/>
-              </a:rPr>
-              <a:t>Capacity value: </a:t>
-            </a:r>
-            <a:r>
-              <a:rPr sz="1200">
-                <a:solidFill>
-                  <a:srgbClr val="333333"/>
-                </a:solidFill>
-                <a:latin typeface="Arial"/>
-              </a:rPr>
-              <a:t>MISO cleared Michigan's zone at $424.30/MW-day for 2026/27 (source: MISO PRA posting) — real, dated, verifiable market signal.</a:t>
-            </a:r>
-          </a:p>
-        </p:txBody>
-      </p:sp>
-      <p:sp>
-        <p:nvSpPr>
-          <p:cNvPr id="7" name="TextBox 6"/>
+                  <a:srgbClr val="FFFFFF"/>
+                </a:solidFill>
+                <a:latin typeface="Arial"/>
+              </a:rPr>
+              <a:t>Phase 2
+Recruit &amp; Enroll</a:t>
+            </a:r>
+          </a:p>
+          <a:p>
+            <a:pPr algn="ctr"/>
+            <a:r>
+              <a:rPr sz="1100">
+                <a:solidFill>
+                  <a:srgbClr val="FFFFFF"/>
+                </a:solidFill>
+                <a:latin typeface="Arial"/>
+              </a:rPr>
+              <a:t>Identify target neighborhoods (outage-prone, high-mandate-value areas); recruit households; execute hosting agreements</a:t>
+            </a:r>
+          </a:p>
+          <a:p>
+            <a:pPr algn="ctr"/>
+            <a:r>
+              <a:rPr sz="1100" b="1" i="1">
+                <a:solidFill>
+                  <a:srgbClr val="FFFFFF"/>
+                </a:solidFill>
+                <a:latin typeface="Arial"/>
+              </a:rPr>
+              <a:t>6-12 mo</a:t>
+            </a:r>
+          </a:p>
+        </p:txBody>
+      </p:sp>
+      <p:sp>
+        <p:nvSpPr>
+          <p:cNvPr id="6" name="Rectangle 5"/>
+          <p:cNvSpPr/>
+          <p:nvPr/>
+        </p:nvSpPr>
+        <p:spPr>
+          <a:xfrm>
+            <a:off x="5943600" y="1508760"/>
+            <a:ext cx="2606040" cy="2606040"/>
+          </a:xfrm>
+          <a:prstGeom prst="rect">
+            <a:avLst/>
+          </a:prstGeom>
+          <a:solidFill>
+            <a:srgbClr val="1B2A5E"/>
+          </a:solidFill>
+          <a:ln>
+            <a:noFill/>
+          </a:ln>
+        </p:spPr>
+        <p:style>
+          <a:lnRef idx="1">
+            <a:schemeClr val="accent1"/>
+          </a:lnRef>
+          <a:fillRef idx="3">
+            <a:schemeClr val="accent1"/>
+          </a:fillRef>
+          <a:effectRef idx="2">
+            <a:schemeClr val="accent1"/>
+          </a:effectRef>
+          <a:fontRef idx="minor">
+            <a:schemeClr val="lt1"/>
+          </a:fontRef>
+        </p:style>
+        <p:txBody>
+          <a:bodyPr rtlCol="0" anchor="ctr" wrap="square" lIns="137160" tIns="137160" rIns="137160"/>
+          <a:lstStyle/>
+          <a:p>
+            <a:pPr algn="ctr"/>
+            <a:r>
+              <a:rPr b="1" sz="1500">
+                <a:solidFill>
+                  <a:srgbClr val="FFFFFF"/>
+                </a:solidFill>
+                <a:latin typeface="Arial"/>
+              </a:rPr>
+              <a:t>Phase 3
+Install &amp; QA</a:t>
+            </a:r>
+          </a:p>
+          <a:p>
+            <a:pPr algn="ctr"/>
+            <a:r>
+              <a:rPr sz="1100">
+                <a:solidFill>
+                  <a:srgbClr val="FFFFFF"/>
+                </a:solidFill>
+                <a:latin typeface="Arial"/>
+              </a:rPr>
+              <a:t>Manage certified contractor network for installation; perform install QA; commission fleet onto dispatch software</a:t>
+            </a:r>
+          </a:p>
+          <a:p>
+            <a:pPr algn="ctr"/>
+            <a:r>
+              <a:rPr sz="1100" b="1" i="1">
+                <a:solidFill>
+                  <a:srgbClr val="FFFFFF"/>
+                </a:solidFill>
+                <a:latin typeface="Arial"/>
+              </a:rPr>
+              <a:t>12-24 mo</a:t>
+            </a:r>
+          </a:p>
+        </p:txBody>
+      </p:sp>
+      <p:sp>
+        <p:nvSpPr>
+          <p:cNvPr id="7" name="Rectangle 6"/>
+          <p:cNvSpPr/>
+          <p:nvPr/>
+        </p:nvSpPr>
+        <p:spPr>
+          <a:xfrm>
+            <a:off x="8686800" y="1508760"/>
+            <a:ext cx="2606040" cy="2606040"/>
+          </a:xfrm>
+          <a:prstGeom prst="rect">
+            <a:avLst/>
+          </a:prstGeom>
+          <a:solidFill>
+            <a:srgbClr val="E87B22"/>
+          </a:solidFill>
+          <a:ln>
+            <a:noFill/>
+          </a:ln>
+        </p:spPr>
+        <p:style>
+          <a:lnRef idx="1">
+            <a:schemeClr val="accent1"/>
+          </a:lnRef>
+          <a:fillRef idx="3">
+            <a:schemeClr val="accent1"/>
+          </a:fillRef>
+          <a:effectRef idx="2">
+            <a:schemeClr val="accent1"/>
+          </a:effectRef>
+          <a:fontRef idx="minor">
+            <a:schemeClr val="lt1"/>
+          </a:fontRef>
+        </p:style>
+        <p:txBody>
+          <a:bodyPr rtlCol="0" anchor="ctr" wrap="square" lIns="137160" tIns="137160" rIns="137160"/>
+          <a:lstStyle/>
+          <a:p>
+            <a:pPr algn="ctr"/>
+            <a:r>
+              <a:rPr b="1" sz="1500">
+                <a:solidFill>
+                  <a:srgbClr val="FFFFFF"/>
+                </a:solidFill>
+                <a:latin typeface="Arial"/>
+              </a:rPr>
+              <a:t>Phase 4
+Operate &amp; Report</a:t>
+            </a:r>
+          </a:p>
+          <a:p>
+            <a:pPr algn="ctr"/>
+            <a:r>
+              <a:rPr sz="1100">
+                <a:solidFill>
+                  <a:srgbClr val="FFFFFF"/>
+                </a:solidFill>
+                <a:latin typeface="Arial"/>
+              </a:rPr>
+              <a:t>Ongoing fleet reporting, compliance documentation, contractor continuity, regulatory filings support</a:t>
+            </a:r>
+          </a:p>
+          <a:p>
+            <a:pPr algn="ctr"/>
+            <a:r>
+              <a:rPr sz="1100" b="1" i="1">
+                <a:solidFill>
+                  <a:srgbClr val="FFFFFF"/>
+                </a:solidFill>
+                <a:latin typeface="Arial"/>
+              </a:rPr>
+              <a:t>24 mo+</a:t>
+            </a:r>
+          </a:p>
+        </p:txBody>
+      </p:sp>
+      <p:sp>
+        <p:nvSpPr>
+          <p:cNvPr id="8" name="TextBox 7"/>
           <p:cNvSpPr txBox="1"/>
           <p:nvPr/>
         </p:nvSpPr>
         <p:spPr>
           <a:xfrm>
-            <a:off x="457200" y="6080760"/>
-            <a:ext cx="11247120" cy="365760"/>
+            <a:off x="2880360" y="2468880"/>
+            <a:ext cx="320040" cy="457200"/>
           </a:xfrm>
           <a:prstGeom prst="rect">
             <a:avLst/>
@@ -3904,28 +3487,28 @@
           </a:bodyPr>
           <a:lstStyle/>
           <a:p>
-            <a:r>
-              <a:rPr sz="1000" i="1">
-                <a:solidFill>
-                  <a:srgbClr val="777777"/>
-                </a:solidFill>
-                <a:latin typeface="Arial"/>
-              </a:rPr>
-              <a:t>Wisconsin (strongest APTIM relationship, weaker economics) and Illinois (best raw pricing, legally blocked for utility ownership) were evaluated and held as separate opportunities.</a:t>
-            </a:r>
-          </a:p>
-        </p:txBody>
-      </p:sp>
-      <p:sp>
-        <p:nvSpPr>
-          <p:cNvPr id="8" name="TextBox 7"/>
+            <a:pPr algn="ctr"/>
+            <a:r>
+              <a:rPr sz="2200" b="1">
+                <a:solidFill>
+                  <a:srgbClr val="1B2A5E"/>
+                </a:solidFill>
+              </a:rPr>
+              <a:t>→</a:t>
+            </a:r>
+          </a:p>
+        </p:txBody>
+      </p:sp>
+      <p:sp>
+        <p:nvSpPr>
+          <p:cNvPr id="9" name="TextBox 8"/>
           <p:cNvSpPr txBox="1"/>
           <p:nvPr/>
         </p:nvSpPr>
         <p:spPr>
           <a:xfrm>
-            <a:off x="274320" y="6492240"/>
-            <a:ext cx="9144000" cy="274320"/>
+            <a:off x="5623560" y="2468880"/>
+            <a:ext cx="320040" cy="457200"/>
           </a:xfrm>
           <a:prstGeom prst="rect">
             <a:avLst/>
@@ -3938,6 +3521,354 @@
           </a:bodyPr>
           <a:lstStyle/>
           <a:p>
+            <a:pPr algn="ctr"/>
+            <a:r>
+              <a:rPr sz="2200" b="1">
+                <a:solidFill>
+                  <a:srgbClr val="1B2A5E"/>
+                </a:solidFill>
+              </a:rPr>
+              <a:t>→</a:t>
+            </a:r>
+          </a:p>
+        </p:txBody>
+      </p:sp>
+      <p:sp>
+        <p:nvSpPr>
+          <p:cNvPr id="10" name="TextBox 9"/>
+          <p:cNvSpPr txBox="1"/>
+          <p:nvPr/>
+        </p:nvSpPr>
+        <p:spPr>
+          <a:xfrm>
+            <a:off x="8366760" y="2468880"/>
+            <a:ext cx="320040" cy="457200"/>
+          </a:xfrm>
+          <a:prstGeom prst="rect">
+            <a:avLst/>
+          </a:prstGeom>
+          <a:noFill/>
+        </p:spPr>
+        <p:txBody>
+          <a:bodyPr wrap="none">
+            <a:spAutoFit/>
+          </a:bodyPr>
+          <a:lstStyle/>
+          <a:p>
+            <a:pPr algn="ctr"/>
+            <a:r>
+              <a:rPr sz="2200" b="1">
+                <a:solidFill>
+                  <a:srgbClr val="1B2A5E"/>
+                </a:solidFill>
+              </a:rPr>
+              <a:t>→</a:t>
+            </a:r>
+          </a:p>
+        </p:txBody>
+      </p:sp>
+      <p:sp>
+        <p:nvSpPr>
+          <p:cNvPr id="11" name="TextBox 10"/>
+          <p:cNvSpPr txBox="1"/>
+          <p:nvPr/>
+        </p:nvSpPr>
+        <p:spPr>
+          <a:xfrm>
+            <a:off x="457200" y="4343400"/>
+            <a:ext cx="11247120" cy="320040"/>
+          </a:xfrm>
+          <a:prstGeom prst="rect">
+            <a:avLst/>
+          </a:prstGeom>
+          <a:noFill/>
+        </p:spPr>
+        <p:txBody>
+          <a:bodyPr wrap="none">
+            <a:spAutoFit/>
+          </a:bodyPr>
+          <a:lstStyle/>
+          <a:p>
+            <a:r>
+              <a:rPr b="1" sz="1400">
+                <a:solidFill>
+                  <a:srgbClr val="E87B22"/>
+                </a:solidFill>
+                <a:latin typeface="Arial"/>
+              </a:rPr>
+              <a:t>Division of Responsibility Throughout</a:t>
+            </a:r>
+          </a:p>
+        </p:txBody>
+      </p:sp>
+      <p:sp>
+        <p:nvSpPr>
+          <p:cNvPr id="12" name="TextBox 11"/>
+          <p:cNvSpPr txBox="1"/>
+          <p:nvPr/>
+        </p:nvSpPr>
+        <p:spPr>
+          <a:xfrm>
+            <a:off x="457200" y="4709160"/>
+            <a:ext cx="5486400" cy="1463040"/>
+          </a:xfrm>
+          <a:prstGeom prst="rect">
+            <a:avLst/>
+          </a:prstGeom>
+          <a:noFill/>
+        </p:spPr>
+        <p:txBody>
+          <a:bodyPr wrap="square">
+            <a:spAutoFit/>
+          </a:bodyPr>
+          <a:lstStyle/>
+          <a:p>
+            <a:pPr>
+              <a:spcAft>
+                <a:spcPts val="400"/>
+              </a:spcAft>
+            </a:pPr>
+            <a:r>
+              <a:rPr b="1" sz="1200">
+                <a:solidFill>
+                  <a:srgbClr val="1B2A5E"/>
+                </a:solidFill>
+                <a:latin typeface="Arial"/>
+              </a:rPr>
+              <a:t>APTIM Owns (all 4 phases)</a:t>
+            </a:r>
+            <a:r>
+              <a:rPr sz="1100">
+                <a:solidFill>
+                  <a:srgbClr val="333333"/>
+                </a:solidFill>
+                <a:latin typeface="Arial"/>
+              </a:rPr>
+              <a:t>• Program administration &amp; compliance reporting</a:t>
+            </a:r>
+          </a:p>
+          <a:p>
+            <a:pPr>
+              <a:spcAft>
+                <a:spcPts val="400"/>
+              </a:spcAft>
+            </a:pPr>
+            <a:r>
+              <a:rPr sz="1100">
+                <a:solidFill>
+                  <a:srgbClr val="333333"/>
+                </a:solidFill>
+                <a:latin typeface="Arial"/>
+              </a:rPr>
+              <a:t>• Contractor network management &amp; install QA</a:t>
+            </a:r>
+          </a:p>
+          <a:p>
+            <a:pPr>
+              <a:spcAft>
+                <a:spcPts val="400"/>
+              </a:spcAft>
+            </a:pPr>
+            <a:r>
+              <a:rPr sz="1100">
+                <a:solidFill>
+                  <a:srgbClr val="333333"/>
+                </a:solidFill>
+                <a:latin typeface="Arial"/>
+              </a:rPr>
+              <a:t>• Household recruitment &amp; hosting agreements</a:t>
+            </a:r>
+          </a:p>
+          <a:p>
+            <a:pPr>
+              <a:spcAft>
+                <a:spcPts val="400"/>
+              </a:spcAft>
+            </a:pPr>
+            <a:r>
+              <a:rPr sz="1100">
+                <a:solidFill>
+                  <a:srgbClr val="333333"/>
+                </a:solidFill>
+                <a:latin typeface="Arial"/>
+              </a:rPr>
+              <a:t>• Utility relationship &amp; regulatory filings support</a:t>
+            </a:r>
+          </a:p>
+        </p:txBody>
+      </p:sp>
+      <p:sp>
+        <p:nvSpPr>
+          <p:cNvPr id="13" name="TextBox 12"/>
+          <p:cNvSpPr txBox="1"/>
+          <p:nvPr/>
+        </p:nvSpPr>
+        <p:spPr>
+          <a:xfrm>
+            <a:off x="6217920" y="4709160"/>
+            <a:ext cx="5486400" cy="1463040"/>
+          </a:xfrm>
+          <a:prstGeom prst="rect">
+            <a:avLst/>
+          </a:prstGeom>
+          <a:noFill/>
+        </p:spPr>
+        <p:txBody>
+          <a:bodyPr wrap="square">
+            <a:spAutoFit/>
+          </a:bodyPr>
+          <a:lstStyle/>
+          <a:p>
+            <a:pPr>
+              <a:spcAft>
+                <a:spcPts val="400"/>
+              </a:spcAft>
+            </a:pPr>
+            <a:r>
+              <a:rPr b="1" sz="1200">
+                <a:solidFill>
+                  <a:srgbClr val="1B2A5E"/>
+                </a:solidFill>
+                <a:latin typeface="Arial"/>
+              </a:rPr>
+              <a:t>Utility Owns (throughout)</a:t>
+            </a:r>
+            <a:r>
+              <a:rPr sz="1100">
+                <a:solidFill>
+                  <a:srgbClr val="333333"/>
+                </a:solidFill>
+                <a:latin typeface="Arial"/>
+              </a:rPr>
+              <a:t>• Capital investment &amp; fleet ownership (rate-based)</a:t>
+            </a:r>
+          </a:p>
+          <a:p>
+            <a:pPr>
+              <a:spcAft>
+                <a:spcPts val="400"/>
+              </a:spcAft>
+            </a:pPr>
+            <a:r>
+              <a:rPr sz="1100">
+                <a:solidFill>
+                  <a:srgbClr val="333333"/>
+                </a:solidFill>
+                <a:latin typeface="Arial"/>
+              </a:rPr>
+              <a:t>• Regulatory approval / rate case</a:t>
+            </a:r>
+          </a:p>
+          <a:p>
+            <a:pPr>
+              <a:spcAft>
+                <a:spcPts val="400"/>
+              </a:spcAft>
+            </a:pPr>
+            <a:r>
+              <a:rPr sz="1100">
+                <a:solidFill>
+                  <a:srgbClr val="333333"/>
+                </a:solidFill>
+                <a:latin typeface="Arial"/>
+              </a:rPr>
+              <a:t>• Dispatch decisions (via software partner)</a:t>
+            </a:r>
+          </a:p>
+          <a:p>
+            <a:pPr>
+              <a:spcAft>
+                <a:spcPts val="400"/>
+              </a:spcAft>
+            </a:pPr>
+            <a:r>
+              <a:rPr sz="1100">
+                <a:solidFill>
+                  <a:srgbClr val="333333"/>
+                </a:solidFill>
+                <a:latin typeface="Arial"/>
+              </a:rPr>
+              <a:t>• Ratepayer billing &amp; cost recovery</a:t>
+            </a:r>
+          </a:p>
+        </p:txBody>
+      </p:sp>
+      <p:sp>
+        <p:nvSpPr>
+          <p:cNvPr id="14" name="Rectangle 13"/>
+          <p:cNvSpPr/>
+          <p:nvPr/>
+        </p:nvSpPr>
+        <p:spPr>
+          <a:xfrm>
+            <a:off x="457200" y="6263640"/>
+            <a:ext cx="11247120" cy="365760"/>
+          </a:xfrm>
+          <a:prstGeom prst="rect">
+            <a:avLst/>
+          </a:prstGeom>
+          <a:solidFill>
+            <a:srgbClr val="FFF6E8"/>
+          </a:solidFill>
+          <a:ln w="12700">
+            <a:solidFill>
+              <a:srgbClr val="E87B22"/>
+            </a:solidFill>
+          </a:ln>
+        </p:spPr>
+        <p:style>
+          <a:lnRef idx="1">
+            <a:schemeClr val="accent1"/>
+          </a:lnRef>
+          <a:fillRef idx="3">
+            <a:schemeClr val="accent1"/>
+          </a:fillRef>
+          <a:effectRef idx="2">
+            <a:schemeClr val="accent1"/>
+          </a:effectRef>
+          <a:fontRef idx="minor">
+            <a:schemeClr val="lt1"/>
+          </a:fontRef>
+        </p:style>
+        <p:txBody>
+          <a:bodyPr rtlCol="0" anchor="ctr" wrap="square" lIns="137160" tIns="91440"/>
+          <a:lstStyle/>
+          <a:p>
+            <a:pPr algn="ctr"/>
+            <a:r>
+              <a:rPr sz="1000" i="1">
+                <a:solidFill>
+                  <a:srgbClr val="664E1A"/>
+                </a:solidFill>
+                <a:latin typeface="Arial"/>
+              </a:rPr>
+              <a:t>APTIM never owns hardware or takes on capital risk at any phase — consistent with its existing role in Focus on Energy and Entergy Energy Smart.</a:t>
+            </a:r>
+          </a:p>
+        </p:txBody>
+      </p:sp>
+      <p:sp>
+        <p:nvSpPr>
+          <p:cNvPr id="15" name="TextBox 14"/>
+          <p:cNvSpPr txBox="1"/>
+          <p:nvPr/>
+        </p:nvSpPr>
+        <p:spPr>
+          <a:xfrm>
+            <a:off x="274320" y="6492240"/>
+            <a:ext cx="9144000" cy="274320"/>
+          </a:xfrm>
+          <a:prstGeom prst="rect">
+            <a:avLst/>
+          </a:prstGeom>
+          <a:noFill/>
+        </p:spPr>
+        <p:txBody>
+          <a:bodyPr wrap="none">
+            <a:spAutoFit/>
+          </a:bodyPr>
+          <a:lstStyle/>
+          <a:p>
             <a:r>
               <a:rPr sz="800">
                 <a:solidFill>
@@ -3952,7 +3883,7 @@
       </p:sp>
       <p:sp>
         <p:nvSpPr>
-          <p:cNvPr id="9" name="TextBox 8"/>
+          <p:cNvPr id="16" name="TextBox 15"/>
           <p:cNvSpPr txBox="1"/>
           <p:nvPr/>
         </p:nvSpPr>
@@ -4031,7 +3962,7 @@
                 </a:solidFill>
                 <a:latin typeface="Arial"/>
               </a:rPr>
-              <a:t>Service Concept: Utility-Owned Battery + Solar Fleet</a:t>
+              <a:t>Service Concept: The APTIM Operating Model</a:t>
             </a:r>
           </a:p>
         </p:txBody>
@@ -4065,7 +3996,7 @@
                 </a:solidFill>
                 <a:latin typeface="Arial"/>
               </a:rPr>
-              <a:t>The utility owns the fleet. APTIM administers it. The household hosts it at no cost.</a:t>
+              <a:t>The utility owns the fleet. APTIM runs the program. The household hosts it at no cost.</a:t>
             </a:r>
           </a:p>
         </p:txBody>
@@ -4079,7 +4010,7 @@
         <p:spPr>
           <a:xfrm>
             <a:off x="457200" y="1371600"/>
-            <a:ext cx="3520440" cy="1554480"/>
+            <a:ext cx="3520440" cy="1371600"/>
           </a:xfrm>
           <a:prstGeom prst="rect">
             <a:avLst/>
@@ -4141,7 +4072,7 @@
                 </a:solidFill>
                 <a:latin typeface="Arial"/>
               </a:rPr>
-              <a:t>Manufactures the battery + solar hardware</a:t>
+              <a:t>Manufactures battery + solar hardware</a:t>
             </a:r>
           </a:p>
         </p:txBody>
@@ -4155,7 +4086,7 @@
         <p:spPr>
           <a:xfrm>
             <a:off x="4114800" y="1371600"/>
-            <a:ext cx="3520440" cy="1554480"/>
+            <a:ext cx="3520440" cy="1371600"/>
           </a:xfrm>
           <a:prstGeom prst="rect">
             <a:avLst/>
@@ -4217,7 +4148,7 @@
                 </a:solidFill>
                 <a:latin typeface="Arial"/>
               </a:rPr>
-              <a:t>Finances, owns, and rate-bases the fleet; recovers cost from all ratepayers; earns regulated return; dispatches at peak via utility or partner software</a:t>
+              <a:t>Finances, owns, rate-bases the fleet; earns regulated return; dispatches via software partner</a:t>
             </a:r>
           </a:p>
         </p:txBody>
@@ -4231,7 +4162,7 @@
         <p:spPr>
           <a:xfrm>
             <a:off x="7772400" y="1371600"/>
-            <a:ext cx="3520440" cy="1554480"/>
+            <a:ext cx="3520440" cy="1371600"/>
           </a:xfrm>
           <a:prstGeom prst="rect">
             <a:avLst/>
@@ -4269,7 +4200,7 @@
                 </a:solidFill>
                 <a:latin typeface="Arial"/>
               </a:rPr>
-              <a:t>Program Administrator (APTIM)</a:t>
+              <a:t>Program Administrator — APTIM</a:t>
             </a:r>
           </a:p>
           <a:p>
@@ -4293,7 +4224,7 @@
                 </a:solidFill>
                 <a:latin typeface="Arial"/>
               </a:rPr>
-              <a:t>Site selection, household recruitment, hosting agreements, contractor network, install QA, fleet reporting, compliance</a:t>
+              <a:t>Runs the program end-to-end — see implementation phases</a:t>
             </a:r>
           </a:p>
         </p:txBody>
@@ -4306,7 +4237,7 @@
         </p:nvSpPr>
         <p:spPr>
           <a:xfrm>
-            <a:off x="3794760" y="1965960"/>
+            <a:off x="3794760" y="1920240"/>
             <a:ext cx="320040" cy="457200"/>
           </a:xfrm>
           <a:prstGeom prst="rect">
@@ -4340,7 +4271,7 @@
         </p:nvSpPr>
         <p:spPr>
           <a:xfrm>
-            <a:off x="7452360" y="1965960"/>
+            <a:off x="7452360" y="1920240"/>
             <a:ext cx="320040" cy="457200"/>
           </a:xfrm>
           <a:prstGeom prst="rect">
@@ -4374,7 +4305,7 @@
         </p:nvSpPr>
         <p:spPr>
           <a:xfrm>
-            <a:off x="457200" y="3063240"/>
+            <a:off x="457200" y="2926080"/>
             <a:ext cx="11247120" cy="594360"/>
           </a:xfrm>
           <a:prstGeom prst="rect">
@@ -4415,7 +4346,7 @@
                 </a:solidFill>
                 <a:latin typeface="Arial"/>
               </a:rPr>
-              <a:t>Who pays: the utility recovers its investment from ALL ratepayers via rate base (standard cost-of-service regulation) -- not a special charge to the hosting household. The household's "payment" for hosting is free backup power and lower bills. This is NOT a Power Purchase Agreement -- the utility owns the asset directly, it does not buy output from a third-party owner.</a:t>
+              <a:t>Who pays: the utility recovers its investment from ALL ratepayers via rate base (standard cost-of-service regulation), not a special charge to the hosting household. This is NOT a Power Purchase Agreement -- the utility owns the asset directly rather than buying output from a third-party owner.</a:t>
             </a:r>
           </a:p>
         </p:txBody>
@@ -4428,7 +4359,7 @@
         </p:nvSpPr>
         <p:spPr>
           <a:xfrm>
-            <a:off x="457200" y="3794760"/>
+            <a:off x="457200" y="3657600"/>
             <a:ext cx="5486400" cy="320040"/>
           </a:xfrm>
           <a:prstGeom prst="rect">
@@ -4462,8 +4393,8 @@
         </p:nvSpPr>
         <p:spPr>
           <a:xfrm>
-            <a:off x="457200" y="4160520"/>
-            <a:ext cx="5486400" cy="1645920"/>
+            <a:off x="457200" y="4023360"/>
+            <a:ext cx="5486400" cy="1737360"/>
           </a:xfrm>
           <a:prstGeom prst="rect">
             <a:avLst/>
@@ -4478,76 +4409,49 @@
           <a:p>
             <a:pPr>
               <a:spcAft>
-                <a:spcPts val="800"/>
+                <a:spcPts val="400"/>
               </a:spcAft>
             </a:pPr>
             <a:r>
-              <a:rPr b="1" sz="1200">
-                <a:solidFill>
-                  <a:srgbClr val="1B2A5E"/>
-                </a:solidFill>
-                <a:latin typeface="Arial"/>
-              </a:rPr>
-              <a:t>Base structure: </a:t>
-            </a:r>
-            <a:r>
               <a:rPr sz="1200">
                 <a:solidFill>
                   <a:srgbClr val="333333"/>
                 </a:solidFill>
                 <a:latin typeface="Arial"/>
               </a:rPr>
-              <a:t>Level-of-effort / cost-plus fee -- consistent with APTIM's existing Focus on Energy model</a:t>
+              <a:t>• Base: level-of-effort / cost-plus fee -- consistent with APTIM's existing Focus on Energy model</a:t>
             </a:r>
           </a:p>
           <a:p>
             <a:pPr>
               <a:spcAft>
-                <a:spcPts val="800"/>
+                <a:spcPts val="400"/>
               </a:spcAft>
             </a:pPr>
             <a:r>
-              <a:rPr b="1" sz="1200">
-                <a:solidFill>
-                  <a:srgbClr val="1B2A5E"/>
-                </a:solidFill>
-                <a:latin typeface="Arial"/>
-              </a:rPr>
-              <a:t>Differentiator: </a:t>
-            </a:r>
-            <a:r>
               <a:rPr sz="1200">
                 <a:solidFill>
                   <a:srgbClr val="333333"/>
                 </a:solidFill>
                 <a:latin typeface="Arial"/>
               </a:rPr>
-              <a:t>Performance incentive tied to fleet uptime/dispatch reliability -- aligns APTIM's incentive with utility outcomes</a:t>
+              <a:t>• Differentiator: performance incentive tied to fleet uptime/dispatch reliability</a:t>
             </a:r>
           </a:p>
           <a:p>
             <a:pPr>
               <a:spcAft>
-                <a:spcPts val="800"/>
+                <a:spcPts val="400"/>
               </a:spcAft>
             </a:pPr>
             <a:r>
-              <a:rPr b="1" sz="1200">
-                <a:solidFill>
-                  <a:srgbClr val="1B2A5E"/>
-                </a:solidFill>
-                <a:latin typeface="Arial"/>
-              </a:rPr>
-              <a:t>Exact terms: </a:t>
-            </a:r>
-            <a:r>
               <a:rPr sz="1200">
                 <a:solidFill>
                   <a:srgbClr val="333333"/>
                 </a:solidFill>
                 <a:latin typeface="Arial"/>
               </a:rPr>
-              <a:t>To be negotiated through the RFP process -- not fixed at this stage</a:t>
+              <a:t>• Exact terms negotiated through the RFP process, not fixed at this stage</a:t>
             </a:r>
           </a:p>
         </p:txBody>
@@ -4560,7 +4464,7 @@
         </p:nvSpPr>
         <p:spPr>
           <a:xfrm>
-            <a:off x="6217920" y="3794760"/>
+            <a:off x="6217920" y="3657600"/>
             <a:ext cx="5486400" cy="320040"/>
           </a:xfrm>
           <a:prstGeom prst="rect">
@@ -4581,7 +4485,7 @@
                 </a:solidFill>
                 <a:latin typeface="Arial"/>
               </a:rPr>
-              <a:t>Why the Client Says Yes</a:t>
+              <a:t>Why APTIM Is the Right Operator</a:t>
             </a:r>
           </a:p>
         </p:txBody>
@@ -4594,8 +4498,8 @@
         </p:nvSpPr>
         <p:spPr>
           <a:xfrm>
-            <a:off x="6217920" y="4160520"/>
-            <a:ext cx="5486400" cy="1645920"/>
+            <a:off x="6217920" y="4023360"/>
+            <a:ext cx="5486400" cy="1737360"/>
           </a:xfrm>
           <a:prstGeom prst="rect">
             <a:avLst/>
@@ -4610,76 +4514,49 @@
           <a:p>
             <a:pPr>
               <a:spcAft>
-                <a:spcPts val="800"/>
+                <a:spcPts val="400"/>
               </a:spcAft>
             </a:pPr>
             <a:r>
-              <a:rPr b="1" sz="1200">
-                <a:solidFill>
-                  <a:srgbClr val="1B2A5E"/>
-                </a:solidFill>
-                <a:latin typeface="Arial"/>
-              </a:rPr>
-              <a:t>Utility: </a:t>
-            </a:r>
-            <a:r>
               <a:rPr sz="1200">
                 <a:solidFill>
                   <a:srgbClr val="333333"/>
                 </a:solidFill>
                 <a:latin typeface="Arial"/>
               </a:rPr>
-              <a:t>Meets statutory storage mandate; cheaper than a new peaker plant; grows rate base</a:t>
+              <a:t>• Already runs this exact lifecycle for Focus on Energy (WI) and Energy Smart (Entergy)</a:t>
             </a:r>
           </a:p>
           <a:p>
             <a:pPr>
               <a:spcAft>
-                <a:spcPts val="800"/>
+                <a:spcPts val="400"/>
               </a:spcAft>
             </a:pPr>
             <a:r>
-              <a:rPr b="1" sz="1200">
-                <a:solidFill>
-                  <a:srgbClr val="1B2A5E"/>
-                </a:solidFill>
-                <a:latin typeface="Arial"/>
-              </a:rPr>
-              <a:t>Household: </a:t>
-            </a:r>
-            <a:r>
               <a:rPr sz="1200">
                 <a:solidFill>
                   <a:srgbClr val="333333"/>
                 </a:solidFill>
                 <a:latin typeface="Arial"/>
               </a:rPr>
-              <a:t>Backup power in the state with the worst outages in the nation, at zero cost</a:t>
+              <a:t>• Existing contractor-network management capability -- the hardest part of scaling a fleet</a:t>
             </a:r>
           </a:p>
           <a:p>
             <a:pPr>
               <a:spcAft>
-                <a:spcPts val="800"/>
+                <a:spcPts val="400"/>
               </a:spcAft>
             </a:pPr>
             <a:r>
-              <a:rPr b="1" sz="1200">
-                <a:solidFill>
-                  <a:srgbClr val="1B2A5E"/>
-                </a:solidFill>
-                <a:latin typeface="Arial"/>
-              </a:rPr>
-              <a:t>Regulator: </a:t>
-            </a:r>
-            <a:r>
               <a:rPr sz="1200">
                 <a:solidFill>
                   <a:srgbClr val="333333"/>
                 </a:solidFill>
                 <a:latin typeface="Arial"/>
               </a:rPr>
-              <a:t>Resilience delivered without a new tax or appropriation</a:t>
+              <a:t>• No company today packages this administrator role end-to-end (see competitive landscape)</a:t>
             </a:r>
           </a:p>
         </p:txBody>
@@ -4713,7 +4590,7 @@
                 </a:solidFill>
                 <a:latin typeface="Arial"/>
               </a:rPr>
-              <a:t>Open items for RFP-stage negotiation: exact fee %, named installer network, interconnection process for utility-owned residential batteries (flagged as a regulatory question to work through with MPSC, not assumed).</a:t>
+              <a:t>Open items for RFP-stage negotiation: exact fee %, named installer network, interconnection process for utility-owned residential batteries.</a:t>
             </a:r>
           </a:p>
         </p:txBody>

</xml_diff>

<commit_message>
Rework prioritization framework slide to justify concept selection vs alternatives
Co-Authored-By: Claude Sonnet 5 <noreply@anthropic.com>
Claude-Session: https://claude.ai/code/session_018Bg71BX6us34ZYpqiy24Sa
</commit_message>
<xml_diff>
--- a/STRIVE_Capstone_Christian_Slides.pptx
+++ b/STRIVE_Capstone_Christian_Slides.pptx
@@ -3118,7 +3118,7 @@
                 </a:solidFill>
                 <a:latin typeface="Arial"/>
               </a:rPr>
-              <a:t>Implementation Approach: How APTIM Runs This Program</a:t>
+              <a:t>Prioritization Framework: Why Battery + Solar Administration</a:t>
             </a:r>
           </a:p>
         </p:txBody>
@@ -3152,7 +3152,781 @@
                 </a:solidFill>
                 <a:latin typeface="Arial"/>
               </a:rPr>
-              <a:t>Four phases, from contract award to ongoing fleet operations — the same lifecycle APTIM already runs for Focus on Energy</a:t>
+              <a:t>Ranked on cost, ease of implementation, and feasibility within 1-3 years</a:t>
+            </a:r>
+          </a:p>
+        </p:txBody>
+      </p:sp>
+      <p:graphicFrame>
+        <p:nvGraphicFramePr>
+          <p:cNvPr id="4" name="Table 3"/>
+          <p:cNvGraphicFramePr>
+            <a:graphicFrameLocks noGrp="1"/>
+          </p:cNvGraphicFramePr>
+          <p:nvPr/>
+        </p:nvGraphicFramePr>
+        <p:xfrm>
+          <a:off x="457200" y="1371600"/>
+          <a:ext cx="11247120" cy="2834640"/>
+        </p:xfrm>
+        <a:graphic>
+          <a:graphicData uri="http://schemas.openxmlformats.org/drawingml/2006/table">
+            <a:tbl>
+              <a:tblPr firstRow="1" bandRow="1">
+                <a:tableStyleId>{5C22544A-7EE6-4342-B048-85BDC9FD1C3A}</a:tableStyleId>
+              </a:tblPr>
+              <a:tblGrid>
+                <a:gridCol w="3291840"/>
+                <a:gridCol w="2286000"/>
+                <a:gridCol w="4114800"/>
+                <a:gridCol w="1554480"/>
+              </a:tblGrid>
+              <a:tr h="566928">
+                <a:tc>
+                  <a:txBody>
+                    <a:bodyPr/>
+                    <a:lstStyle/>
+                    <a:p>
+                      <a:pPr>
+                        <a:defRPr sz="1100" b="1">
+                          <a:solidFill>
+                            <a:srgbClr val="FFFFFF"/>
+                          </a:solidFill>
+                          <a:latin typeface="Arial"/>
+                        </a:defRPr>
+                      </a:pPr>
+                      <a:r>
+                        <a:t>Approach Considered</a:t>
+                      </a:r>
+                    </a:p>
+                  </a:txBody>
+                  <a:tcPr>
+                    <a:solidFill>
+                      <a:srgbClr val="1B2A5E"/>
+                    </a:solidFill>
+                  </a:tcPr>
+                </a:tc>
+                <a:tc>
+                  <a:txBody>
+                    <a:bodyPr/>
+                    <a:lstStyle/>
+                    <a:p>
+                      <a:pPr>
+                        <a:defRPr sz="1100" b="1">
+                          <a:solidFill>
+                            <a:srgbClr val="FFFFFF"/>
+                          </a:solidFill>
+                          <a:latin typeface="Arial"/>
+                        </a:defRPr>
+                      </a:pPr>
+                      <a:r>
+                        <a:t>1-3 Yr Feasibility</a:t>
+                      </a:r>
+                    </a:p>
+                  </a:txBody>
+                  <a:tcPr>
+                    <a:solidFill>
+                      <a:srgbClr val="1B2A5E"/>
+                    </a:solidFill>
+                  </a:tcPr>
+                </a:tc>
+                <a:tc>
+                  <a:txBody>
+                    <a:bodyPr/>
+                    <a:lstStyle/>
+                    <a:p>
+                      <a:pPr>
+                        <a:defRPr sz="1100" b="1">
+                          <a:solidFill>
+                            <a:srgbClr val="FFFFFF"/>
+                          </a:solidFill>
+                          <a:latin typeface="Arial"/>
+                        </a:defRPr>
+                      </a:pPr>
+                      <a:r>
+                        <a:t>Key Risk</a:t>
+                      </a:r>
+                    </a:p>
+                  </a:txBody>
+                  <a:tcPr>
+                    <a:solidFill>
+                      <a:srgbClr val="1B2A5E"/>
+                    </a:solidFill>
+                  </a:tcPr>
+                </a:tc>
+                <a:tc>
+                  <a:txBody>
+                    <a:bodyPr/>
+                    <a:lstStyle/>
+                    <a:p>
+                      <a:pPr>
+                        <a:defRPr sz="1100" b="1">
+                          <a:solidFill>
+                            <a:srgbClr val="FFFFFF"/>
+                          </a:solidFill>
+                          <a:latin typeface="Arial"/>
+                        </a:defRPr>
+                      </a:pPr>
+                      <a:r>
+                        <a:t>Verdict</a:t>
+                      </a:r>
+                    </a:p>
+                  </a:txBody>
+                  <a:tcPr>
+                    <a:solidFill>
+                      <a:srgbClr val="1B2A5E"/>
+                    </a:solidFill>
+                  </a:tcPr>
+                </a:tc>
+              </a:tr>
+              <a:tr h="566928">
+                <a:tc>
+                  <a:txBody>
+                    <a:bodyPr/>
+                    <a:lstStyle/>
+                    <a:p>
+                      <a:pPr>
+                        <a:defRPr sz="1100">
+                          <a:solidFill>
+                            <a:srgbClr val="333333"/>
+                          </a:solidFill>
+                          <a:latin typeface="Arial"/>
+                        </a:defRPr>
+                      </a:pPr>
+                      <a:r>
+                        <a:t>AI-Enabled Reporting/Documentation Tools</a:t>
+                      </a:r>
+                    </a:p>
+                  </a:txBody>
+                  <a:tcPr>
+                    <a:solidFill>
+                      <a:srgbClr val="FCE9E9"/>
+                    </a:solidFill>
+                  </a:tcPr>
+                </a:tc>
+                <a:tc>
+                  <a:txBody>
+                    <a:bodyPr/>
+                    <a:lstStyle/>
+                    <a:p>
+                      <a:pPr>
+                        <a:defRPr sz="1100">
+                          <a:solidFill>
+                            <a:srgbClr val="333333"/>
+                          </a:solidFill>
+                          <a:latin typeface="Arial"/>
+                        </a:defRPr>
+                      </a:pPr>
+                      <a:r>
+                        <a:t>Low-Medium — unproven at program scale</a:t>
+                      </a:r>
+                    </a:p>
+                  </a:txBody>
+                  <a:tcPr>
+                    <a:solidFill>
+                      <a:srgbClr val="FCE9E9"/>
+                    </a:solidFill>
+                  </a:tcPr>
+                </a:tc>
+                <a:tc>
+                  <a:txBody>
+                    <a:bodyPr/>
+                    <a:lstStyle/>
+                    <a:p>
+                      <a:pPr>
+                        <a:defRPr sz="1100">
+                          <a:solidFill>
+                            <a:srgbClr val="333333"/>
+                          </a:solidFill>
+                          <a:latin typeface="Arial"/>
+                        </a:defRPr>
+                      </a:pPr>
+                      <a:r>
+                        <a:t>Data security concerns raised internally at Town Hall (sensitive program data, no governance model yet)</a:t>
+                      </a:r>
+                    </a:p>
+                  </a:txBody>
+                  <a:tcPr>
+                    <a:solidFill>
+                      <a:srgbClr val="FCE9E9"/>
+                    </a:solidFill>
+                  </a:tcPr>
+                </a:tc>
+                <a:tc>
+                  <a:txBody>
+                    <a:bodyPr/>
+                    <a:lstStyle/>
+                    <a:p>
+                      <a:pPr>
+                        <a:defRPr sz="1100">
+                          <a:solidFill>
+                            <a:srgbClr val="333333"/>
+                          </a:solidFill>
+                          <a:latin typeface="Arial"/>
+                        </a:defRPr>
+                      </a:pPr>
+                      <a:r>
+                        <a:t>ELIMINATED</a:t>
+                      </a:r>
+                    </a:p>
+                  </a:txBody>
+                  <a:tcPr>
+                    <a:solidFill>
+                      <a:srgbClr val="FCE9E9"/>
+                    </a:solidFill>
+                  </a:tcPr>
+                </a:tc>
+              </a:tr>
+              <a:tr h="566928">
+                <a:tc>
+                  <a:txBody>
+                    <a:bodyPr/>
+                    <a:lstStyle/>
+                    <a:p>
+                      <a:pPr>
+                        <a:defRPr sz="1100">
+                          <a:solidFill>
+                            <a:srgbClr val="333333"/>
+                          </a:solidFill>
+                          <a:latin typeface="Arial"/>
+                        </a:defRPr>
+                      </a:pPr>
+                      <a:r>
+                        <a:t>Broad "Program Resilience Toolkit" (generic, multi-module)</a:t>
+                      </a:r>
+                    </a:p>
+                  </a:txBody>
+                  <a:tcPr>
+                    <a:solidFill>
+                      <a:srgbClr val="FCE9E9"/>
+                    </a:solidFill>
+                  </a:tcPr>
+                </a:tc>
+                <a:tc>
+                  <a:txBody>
+                    <a:bodyPr/>
+                    <a:lstStyle/>
+                    <a:p>
+                      <a:pPr>
+                        <a:defRPr sz="1100">
+                          <a:solidFill>
+                            <a:srgbClr val="333333"/>
+                          </a:solidFill>
+                          <a:latin typeface="Arial"/>
+                        </a:defRPr>
+                      </a:pPr>
+                      <a:r>
+                        <a:t>Medium — every module individually feasible, but no single concrete offer</a:t>
+                      </a:r>
+                    </a:p>
+                  </a:txBody>
+                  <a:tcPr>
+                    <a:solidFill>
+                      <a:srgbClr val="FCE9E9"/>
+                    </a:solidFill>
+                  </a:tcPr>
+                </a:tc>
+                <a:tc>
+                  <a:txBody>
+                    <a:bodyPr/>
+                    <a:lstStyle/>
+                    <a:p>
+                      <a:pPr>
+                        <a:defRPr sz="1100">
+                          <a:solidFill>
+                            <a:srgbClr val="333333"/>
+                          </a:solidFill>
+                          <a:latin typeface="Arial"/>
+                        </a:defRPr>
+                      </a:pPr>
+                      <a:r>
+                        <a:t>Leadership explicitly asked for a specific program, not a broad toolkit (Sam's guidance)</a:t>
+                      </a:r>
+                    </a:p>
+                  </a:txBody>
+                  <a:tcPr>
+                    <a:solidFill>
+                      <a:srgbClr val="FCE9E9"/>
+                    </a:solidFill>
+                  </a:tcPr>
+                </a:tc>
+                <a:tc>
+                  <a:txBody>
+                    <a:bodyPr/>
+                    <a:lstStyle/>
+                    <a:p>
+                      <a:pPr>
+                        <a:defRPr sz="1100">
+                          <a:solidFill>
+                            <a:srgbClr val="333333"/>
+                          </a:solidFill>
+                          <a:latin typeface="Arial"/>
+                        </a:defRPr>
+                      </a:pPr>
+                      <a:r>
+                        <a:t>ELIMINATED as standalone pitch</a:t>
+                      </a:r>
+                    </a:p>
+                  </a:txBody>
+                  <a:tcPr>
+                    <a:solidFill>
+                      <a:srgbClr val="FCE9E9"/>
+                    </a:solidFill>
+                  </a:tcPr>
+                </a:tc>
+              </a:tr>
+              <a:tr h="566928">
+                <a:tc>
+                  <a:txBody>
+                    <a:bodyPr/>
+                    <a:lstStyle/>
+                    <a:p>
+                      <a:pPr>
+                        <a:defRPr sz="1100">
+                          <a:solidFill>
+                            <a:srgbClr val="333333"/>
+                          </a:solidFill>
+                          <a:latin typeface="Arial"/>
+                        </a:defRPr>
+                      </a:pPr>
+                      <a:r>
+                        <a:t>Infrastructure Overhaul / New Generation (incl. nuclear/SMRs)</a:t>
+                      </a:r>
+                    </a:p>
+                  </a:txBody>
+                  <a:tcPr>
+                    <a:solidFill>
+                      <a:srgbClr val="FCE9E9"/>
+                    </a:solidFill>
+                  </a:tcPr>
+                </a:tc>
+                <a:tc>
+                  <a:txBody>
+                    <a:bodyPr/>
+                    <a:lstStyle/>
+                    <a:p>
+                      <a:pPr>
+                        <a:defRPr sz="1100">
+                          <a:solidFill>
+                            <a:srgbClr val="333333"/>
+                          </a:solidFill>
+                          <a:latin typeface="Arial"/>
+                        </a:defRPr>
+                      </a:pPr>
+                      <a:r>
+                        <a:t>Low — multi-decade timelines, capital scale far beyond a services pitch</a:t>
+                      </a:r>
+                    </a:p>
+                  </a:txBody>
+                  <a:tcPr>
+                    <a:solidFill>
+                      <a:srgbClr val="FCE9E9"/>
+                    </a:solidFill>
+                  </a:tcPr>
+                </a:tc>
+                <a:tc>
+                  <a:txBody>
+                    <a:bodyPr/>
+                    <a:lstStyle/>
+                    <a:p>
+                      <a:pPr>
+                        <a:defRPr sz="1100">
+                          <a:solidFill>
+                            <a:srgbClr val="333333"/>
+                          </a:solidFill>
+                          <a:latin typeface="Arial"/>
+                        </a:defRPr>
+                      </a:pPr>
+                      <a:r>
+                        <a:t>Requires owning generation assets; outside APTIM's business model entirely</a:t>
+                      </a:r>
+                    </a:p>
+                  </a:txBody>
+                  <a:tcPr>
+                    <a:solidFill>
+                      <a:srgbClr val="FCE9E9"/>
+                    </a:solidFill>
+                  </a:tcPr>
+                </a:tc>
+                <a:tc>
+                  <a:txBody>
+                    <a:bodyPr/>
+                    <a:lstStyle/>
+                    <a:p>
+                      <a:pPr>
+                        <a:defRPr sz="1100">
+                          <a:solidFill>
+                            <a:srgbClr val="333333"/>
+                          </a:solidFill>
+                          <a:latin typeface="Arial"/>
+                        </a:defRPr>
+                      </a:pPr>
+                      <a:r>
+                        <a:t>ELIMINATED</a:t>
+                      </a:r>
+                    </a:p>
+                  </a:txBody>
+                  <a:tcPr>
+                    <a:solidFill>
+                      <a:srgbClr val="FCE9E9"/>
+                    </a:solidFill>
+                  </a:tcPr>
+                </a:tc>
+              </a:tr>
+              <a:tr h="566928">
+                <a:tc>
+                  <a:txBody>
+                    <a:bodyPr/>
+                    <a:lstStyle/>
+                    <a:p>
+                      <a:pPr>
+                        <a:defRPr sz="1100">
+                          <a:solidFill>
+                            <a:srgbClr val="333333"/>
+                          </a:solidFill>
+                          <a:latin typeface="Arial"/>
+                        </a:defRPr>
+                      </a:pPr>
+                      <a:r>
+                        <a:t>Utility-Owned Battery + Solar Fleet, APTIM-Administered</a:t>
+                      </a:r>
+                    </a:p>
+                  </a:txBody>
+                  <a:tcPr>
+                    <a:solidFill>
+                      <a:srgbClr val="E3F2E1"/>
+                    </a:solidFill>
+                  </a:tcPr>
+                </a:tc>
+                <a:tc>
+                  <a:txBody>
+                    <a:bodyPr/>
+                    <a:lstStyle/>
+                    <a:p>
+                      <a:pPr>
+                        <a:defRPr sz="1100">
+                          <a:solidFill>
+                            <a:srgbClr val="333333"/>
+                          </a:solidFill>
+                          <a:latin typeface="Arial"/>
+                        </a:defRPr>
+                      </a:pPr>
+                      <a:r>
+                        <a:t>High — matches an existing, proven APTIM capability</a:t>
+                      </a:r>
+                    </a:p>
+                  </a:txBody>
+                  <a:tcPr>
+                    <a:solidFill>
+                      <a:srgbClr val="E3F2E1"/>
+                    </a:solidFill>
+                  </a:tcPr>
+                </a:tc>
+                <a:tc>
+                  <a:txBody>
+                    <a:bodyPr/>
+                    <a:lstStyle/>
+                    <a:p>
+                      <a:pPr>
+                        <a:defRPr sz="1100">
+                          <a:solidFill>
+                            <a:srgbClr val="333333"/>
+                          </a:solidFill>
+                          <a:latin typeface="Arial"/>
+                        </a:defRPr>
+                      </a:pPr>
+                      <a:r>
+                        <a:t>Requires a new utility relationship (market-entry, not incumbency) — addressed via RFP strategy</a:t>
+                      </a:r>
+                    </a:p>
+                  </a:txBody>
+                  <a:tcPr>
+                    <a:solidFill>
+                      <a:srgbClr val="E3F2E1"/>
+                    </a:solidFill>
+                  </a:tcPr>
+                </a:tc>
+                <a:tc>
+                  <a:txBody>
+                    <a:bodyPr/>
+                    <a:lstStyle/>
+                    <a:p>
+                      <a:pPr>
+                        <a:defRPr sz="1100">
+                          <a:solidFill>
+                            <a:srgbClr val="333333"/>
+                          </a:solidFill>
+                          <a:latin typeface="Arial"/>
+                        </a:defRPr>
+                      </a:pPr>
+                      <a:r>
+                        <a:t>SELECTED</a:t>
+                      </a:r>
+                    </a:p>
+                  </a:txBody>
+                  <a:tcPr>
+                    <a:solidFill>
+                      <a:srgbClr val="E3F2E1"/>
+                    </a:solidFill>
+                  </a:tcPr>
+                </a:tc>
+              </a:tr>
+            </a:tbl>
+          </a:graphicData>
+        </a:graphic>
+      </p:graphicFrame>
+      <p:sp>
+        <p:nvSpPr>
+          <p:cNvPr id="5" name="Rectangle 4"/>
+          <p:cNvSpPr/>
+          <p:nvPr/>
+        </p:nvSpPr>
+        <p:spPr>
+          <a:xfrm>
+            <a:off x="457200" y="4434840"/>
+            <a:ext cx="11247120" cy="1508760"/>
+          </a:xfrm>
+          <a:prstGeom prst="rect">
+            <a:avLst/>
+          </a:prstGeom>
+          <a:solidFill>
+            <a:srgbClr val="F2F4F8"/>
+          </a:solidFill>
+          <a:ln w="19050">
+            <a:solidFill>
+              <a:srgbClr val="E87B22"/>
+            </a:solidFill>
+          </a:ln>
+        </p:spPr>
+        <p:style>
+          <a:lnRef idx="1">
+            <a:schemeClr val="accent1"/>
+          </a:lnRef>
+          <a:fillRef idx="3">
+            <a:schemeClr val="accent1"/>
+          </a:fillRef>
+          <a:effectRef idx="2">
+            <a:schemeClr val="accent1"/>
+          </a:effectRef>
+          <a:fontRef idx="minor">
+            <a:schemeClr val="lt1"/>
+          </a:fontRef>
+        </p:style>
+        <p:txBody>
+          <a:bodyPr rtlCol="0" anchor="ctr" wrap="square" lIns="182880" tIns="109728"/>
+          <a:lstStyle/>
+          <a:p>
+            <a:pPr algn="ctr"/>
+            <a:r>
+              <a:rPr b="1" sz="1400">
+                <a:solidFill>
+                  <a:srgbClr val="1B2A5E"/>
+                </a:solidFill>
+                <a:latin typeface="Arial"/>
+              </a:rPr>
+              <a:t>Why This Is the Most Feasible Route</a:t>
+            </a:r>
+          </a:p>
+          <a:p>
+            <a:pPr>
+              <a:spcAft>
+                <a:spcPts val="300"/>
+              </a:spcAft>
+            </a:pPr>
+            <a:r>
+              <a:rPr sz="1100">
+                <a:solidFill>
+                  <a:srgbClr val="333333"/>
+                </a:solidFill>
+                <a:latin typeface="Arial"/>
+              </a:rPr>
+              <a:t>• APTIM already runs rebate programs and full program administration for energy efficiency across multiple states (Focus on Energy/WI, Texas SECO, NC HOMES/HEAR, Entergy LA/New Orleans) — this is a proven, repeatable core competency, not a new capability we'd need to build.</a:t>
+            </a:r>
+          </a:p>
+          <a:p>
+            <a:pPr>
+              <a:spcAft>
+                <a:spcPts val="300"/>
+              </a:spcAft>
+            </a:pPr>
+            <a:r>
+              <a:rPr sz="1100">
+                <a:solidFill>
+                  <a:srgbClr val="333333"/>
+                </a:solidFill>
+                <a:latin typeface="Arial"/>
+              </a:rPr>
+              <a:t>• This approach applies that same administration model to a new asset type (batteries) rather than a new business function — the lowest-risk form of expansion.</a:t>
+            </a:r>
+          </a:p>
+          <a:p>
+            <a:pPr>
+              <a:spcAft>
+                <a:spcPts val="300"/>
+              </a:spcAft>
+            </a:pPr>
+            <a:r>
+              <a:rPr sz="1100">
+                <a:solidFill>
+                  <a:srgbClr val="333333"/>
+                </a:solidFill>
+                <a:latin typeface="Arial"/>
+              </a:rPr>
+              <a:t>• No new technology, no new APTIM business line (no hardware ownership, no capital risk) — it's the same job APTIM does today, for a utility that needs it.</a:t>
+            </a:r>
+          </a:p>
+        </p:txBody>
+      </p:sp>
+      <p:sp>
+        <p:nvSpPr>
+          <p:cNvPr id="6" name="TextBox 5"/>
+          <p:cNvSpPr txBox="1"/>
+          <p:nvPr/>
+        </p:nvSpPr>
+        <p:spPr>
+          <a:xfrm>
+            <a:off x="274320" y="6492240"/>
+            <a:ext cx="9144000" cy="274320"/>
+          </a:xfrm>
+          <a:prstGeom prst="rect">
+            <a:avLst/>
+          </a:prstGeom>
+          <a:noFill/>
+        </p:spPr>
+        <p:txBody>
+          <a:bodyPr wrap="none">
+            <a:spAutoFit/>
+          </a:bodyPr>
+          <a:lstStyle/>
+          <a:p>
+            <a:r>
+              <a:rPr sz="800">
+                <a:solidFill>
+                  <a:srgbClr val="888888"/>
+                </a:solidFill>
+                <a:latin typeface="Arial"/>
+              </a:rPr>
+              <a:t>Confidential. Not to be copied, distributed, or reproduced without prior approval. © 2026 APTIM - All rights reserved.</a:t>
+            </a:r>
+          </a:p>
+        </p:txBody>
+      </p:sp>
+      <p:sp>
+        <p:nvSpPr>
+          <p:cNvPr id="7" name="TextBox 6"/>
+          <p:cNvSpPr txBox="1"/>
+          <p:nvPr/>
+        </p:nvSpPr>
+        <p:spPr>
+          <a:xfrm>
+            <a:off x="11612880" y="6492240"/>
+            <a:ext cx="457200" cy="274320"/>
+          </a:xfrm>
+          <a:prstGeom prst="rect">
+            <a:avLst/>
+          </a:prstGeom>
+          <a:noFill/>
+        </p:spPr>
+        <p:txBody>
+          <a:bodyPr wrap="none">
+            <a:spAutoFit/>
+          </a:bodyPr>
+          <a:lstStyle/>
+          <a:p>
+            <a:r>
+              <a:rPr sz="800">
+                <a:solidFill>
+                  <a:srgbClr val="888888"/>
+                </a:solidFill>
+                <a:latin typeface="Arial"/>
+              </a:rPr>
+              <a:t>1</a:t>
+            </a:r>
+          </a:p>
+        </p:txBody>
+      </p:sp>
+    </p:spTree>
+  </p:cSld>
+  <p:clrMapOvr>
+    <a:masterClrMapping/>
+  </p:clrMapOvr>
+</p:sld>
+</file>
+
+<file path=ppt/slides/slide2.xml><?xml version="1.0" encoding="utf-8"?>
+<p:sld xmlns:a="http://schemas.openxmlformats.org/drawingml/2006/main" xmlns:p="http://schemas.openxmlformats.org/presentationml/2006/main" xmlns:r="http://schemas.openxmlformats.org/officeDocument/2006/relationships">
+  <p:cSld>
+    <p:spTree>
+      <p:nvGrpSpPr>
+        <p:cNvPr id="1" name=""/>
+        <p:cNvGrpSpPr/>
+        <p:nvPr/>
+      </p:nvGrpSpPr>
+      <p:grpSpPr/>
+      <p:sp>
+        <p:nvSpPr>
+          <p:cNvPr id="2" name="TextBox 1"/>
+          <p:cNvSpPr txBox="1"/>
+          <p:nvPr/>
+        </p:nvSpPr>
+        <p:spPr>
+          <a:xfrm>
+            <a:off x="457200" y="228600"/>
+            <a:ext cx="11247120" cy="731520"/>
+          </a:xfrm>
+          <a:prstGeom prst="rect">
+            <a:avLst/>
+          </a:prstGeom>
+          <a:noFill/>
+        </p:spPr>
+        <p:txBody>
+          <a:bodyPr wrap="square">
+            <a:spAutoFit/>
+          </a:bodyPr>
+          <a:lstStyle/>
+          <a:p>
+            <a:r>
+              <a:rPr sz="2600" b="1">
+                <a:solidFill>
+                  <a:srgbClr val="1B2A5E"/>
+                </a:solidFill>
+                <a:latin typeface="Arial"/>
+              </a:rPr>
+              <a:t>Service Concept: The APTIM Operating Model</a:t>
+            </a:r>
+          </a:p>
+        </p:txBody>
+      </p:sp>
+      <p:sp>
+        <p:nvSpPr>
+          <p:cNvPr id="3" name="TextBox 2"/>
+          <p:cNvSpPr txBox="1"/>
+          <p:nvPr/>
+        </p:nvSpPr>
+        <p:spPr>
+          <a:xfrm>
+            <a:off x="457200" y="914400"/>
+            <a:ext cx="11247120" cy="365760"/>
+          </a:xfrm>
+          <a:prstGeom prst="rect">
+            <a:avLst/>
+          </a:prstGeom>
+          <a:noFill/>
+        </p:spPr>
+        <p:txBody>
+          <a:bodyPr wrap="none">
+            <a:spAutoFit/>
+          </a:bodyPr>
+          <a:lstStyle/>
+          <a:p>
+            <a:r>
+              <a:rPr sz="1400" i="1">
+                <a:solidFill>
+                  <a:srgbClr val="777777"/>
+                </a:solidFill>
+                <a:latin typeface="Arial"/>
+              </a:rPr>
+              <a:t>The utility owns the fleet. APTIM runs the program. The household hosts it at no cost.</a:t>
             </a:r>
           </a:p>
         </p:txBody>
@@ -3165,8 +3939,84 @@
         </p:nvSpPr>
         <p:spPr>
           <a:xfrm>
-            <a:off x="457200" y="1508760"/>
-            <a:ext cx="2606040" cy="2606040"/>
+            <a:off x="457200" y="1371600"/>
+            <a:ext cx="3520440" cy="1554480"/>
+          </a:xfrm>
+          <a:prstGeom prst="rect">
+            <a:avLst/>
+          </a:prstGeom>
+          <a:solidFill>
+            <a:srgbClr val="8A8A8A"/>
+          </a:solidFill>
+          <a:ln>
+            <a:noFill/>
+          </a:ln>
+        </p:spPr>
+        <p:style>
+          <a:lnRef idx="1">
+            <a:schemeClr val="accent1"/>
+          </a:lnRef>
+          <a:fillRef idx="3">
+            <a:schemeClr val="accent1"/>
+          </a:fillRef>
+          <a:effectRef idx="2">
+            <a:schemeClr val="accent1"/>
+          </a:effectRef>
+          <a:fontRef idx="minor">
+            <a:schemeClr val="lt1"/>
+          </a:fontRef>
+        </p:style>
+        <p:txBody>
+          <a:bodyPr rtlCol="0" anchor="ctr" wrap="square" lIns="137160" tIns="109728" rIns="137160"/>
+          <a:lstStyle/>
+          <a:p>
+            <a:pPr algn="ctr"/>
+            <a:r>
+              <a:rPr b="1" sz="1300">
+                <a:solidFill>
+                  <a:srgbClr val="FFFFFF"/>
+                </a:solidFill>
+                <a:latin typeface="Arial"/>
+              </a:rPr>
+              <a:t>Hardware Maker</a:t>
+            </a:r>
+          </a:p>
+          <a:p>
+            <a:pPr algn="ctr"/>
+            <a:r>
+              <a:rPr b="1" sz="1200">
+                <a:solidFill>
+                  <a:srgbClr val="FFFFFF"/>
+                </a:solidFill>
+                <a:latin typeface="Arial"/>
+              </a:rPr>
+              <a:t>e.g., Tesla, Enphase</a:t>
+            </a:r>
+          </a:p>
+          <a:p>
+            <a:pPr algn="ctr"/>
+            <a:r>
+              <a:rPr sz="1000">
+                <a:solidFill>
+                  <a:srgbClr val="FFFFFF"/>
+                </a:solidFill>
+                <a:latin typeface="Arial"/>
+              </a:rPr>
+              <a:t>Manufactures battery + solar hardware</a:t>
+            </a:r>
+          </a:p>
+        </p:txBody>
+      </p:sp>
+      <p:sp>
+        <p:nvSpPr>
+          <p:cNvPr id="5" name="Rectangle 4"/>
+          <p:cNvSpPr/>
+          <p:nvPr/>
+        </p:nvSpPr>
+        <p:spPr>
+          <a:xfrm>
+            <a:off x="4114800" y="1371600"/>
+            <a:ext cx="3520440" cy="1554480"/>
           </a:xfrm>
           <a:prstGeom prst="rect">
             <a:avLst/>
@@ -3193,57 +4043,56 @@
           </a:fontRef>
         </p:style>
         <p:txBody>
-          <a:bodyPr rtlCol="0" anchor="ctr" wrap="square" lIns="137160" tIns="137160" rIns="137160"/>
+          <a:bodyPr rtlCol="0" anchor="ctr" wrap="square" lIns="137160" tIns="109728" rIns="137160"/>
           <a:lstStyle/>
           <a:p>
             <a:pPr algn="ctr"/>
             <a:r>
-              <a:rPr b="1" sz="1500">
+              <a:rPr b="1" sz="1300">
                 <a:solidFill>
                   <a:srgbClr val="FFFFFF"/>
                 </a:solidFill>
                 <a:latin typeface="Arial"/>
               </a:rPr>
-              <a:t>Phase 1
-Win &amp; Design</a:t>
+              <a:t>Asset Owner + Dispatcher</a:t>
             </a:r>
           </a:p>
           <a:p>
             <a:pPr algn="ctr"/>
             <a:r>
-              <a:rPr sz="1100">
+              <a:rPr b="1" sz="1200">
                 <a:solidFill>
                   <a:srgbClr val="FFFFFF"/>
                 </a:solidFill>
                 <a:latin typeface="Arial"/>
               </a:rPr>
-              <a:t>Respond to utility RFP; design program rules, eligibility criteria, and rate-case support materials</a:t>
+              <a:t>The Utility</a:t>
             </a:r>
           </a:p>
           <a:p>
             <a:pPr algn="ctr"/>
             <a:r>
-              <a:rPr sz="1100" b="1" i="1">
+              <a:rPr sz="1000">
                 <a:solidFill>
                   <a:srgbClr val="FFFFFF"/>
                 </a:solidFill>
                 <a:latin typeface="Arial"/>
               </a:rPr>
-              <a:t>0-6 mo</a:t>
-            </a:r>
-          </a:p>
-        </p:txBody>
-      </p:sp>
-      <p:sp>
-        <p:nvSpPr>
-          <p:cNvPr id="5" name="Rectangle 4"/>
+              <a:t>Finances, owns, rate-bases the fleet; earns regulated return; dispatches via software partner</a:t>
+            </a:r>
+          </a:p>
+        </p:txBody>
+      </p:sp>
+      <p:sp>
+        <p:nvSpPr>
+          <p:cNvPr id="6" name="Rectangle 5"/>
           <p:cNvSpPr/>
           <p:nvPr/>
         </p:nvSpPr>
         <p:spPr>
           <a:xfrm>
-            <a:off x="3200400" y="1508760"/>
-            <a:ext cx="2606040" cy="2606040"/>
+            <a:off x="7772400" y="1371600"/>
+            <a:ext cx="3520440" cy="1554480"/>
           </a:xfrm>
           <a:prstGeom prst="rect">
             <a:avLst/>
@@ -3270,925 +4119,6 @@
           </a:fontRef>
         </p:style>
         <p:txBody>
-          <a:bodyPr rtlCol="0" anchor="ctr" wrap="square" lIns="137160" tIns="137160" rIns="137160"/>
-          <a:lstStyle/>
-          <a:p>
-            <a:pPr algn="ctr"/>
-            <a:r>
-              <a:rPr b="1" sz="1500">
-                <a:solidFill>
-                  <a:srgbClr val="FFFFFF"/>
-                </a:solidFill>
-                <a:latin typeface="Arial"/>
-              </a:rPr>
-              <a:t>Phase 2
-Recruit &amp; Enroll</a:t>
-            </a:r>
-          </a:p>
-          <a:p>
-            <a:pPr algn="ctr"/>
-            <a:r>
-              <a:rPr sz="1100">
-                <a:solidFill>
-                  <a:srgbClr val="FFFFFF"/>
-                </a:solidFill>
-                <a:latin typeface="Arial"/>
-              </a:rPr>
-              <a:t>Identify target neighborhoods (outage-prone, high-mandate-value areas); recruit households; execute hosting agreements</a:t>
-            </a:r>
-          </a:p>
-          <a:p>
-            <a:pPr algn="ctr"/>
-            <a:r>
-              <a:rPr sz="1100" b="1" i="1">
-                <a:solidFill>
-                  <a:srgbClr val="FFFFFF"/>
-                </a:solidFill>
-                <a:latin typeface="Arial"/>
-              </a:rPr>
-              <a:t>6-12 mo</a:t>
-            </a:r>
-          </a:p>
-        </p:txBody>
-      </p:sp>
-      <p:sp>
-        <p:nvSpPr>
-          <p:cNvPr id="6" name="Rectangle 5"/>
-          <p:cNvSpPr/>
-          <p:nvPr/>
-        </p:nvSpPr>
-        <p:spPr>
-          <a:xfrm>
-            <a:off x="5943600" y="1508760"/>
-            <a:ext cx="2606040" cy="2606040"/>
-          </a:xfrm>
-          <a:prstGeom prst="rect">
-            <a:avLst/>
-          </a:prstGeom>
-          <a:solidFill>
-            <a:srgbClr val="1B2A5E"/>
-          </a:solidFill>
-          <a:ln>
-            <a:noFill/>
-          </a:ln>
-        </p:spPr>
-        <p:style>
-          <a:lnRef idx="1">
-            <a:schemeClr val="accent1"/>
-          </a:lnRef>
-          <a:fillRef idx="3">
-            <a:schemeClr val="accent1"/>
-          </a:fillRef>
-          <a:effectRef idx="2">
-            <a:schemeClr val="accent1"/>
-          </a:effectRef>
-          <a:fontRef idx="minor">
-            <a:schemeClr val="lt1"/>
-          </a:fontRef>
-        </p:style>
-        <p:txBody>
-          <a:bodyPr rtlCol="0" anchor="ctr" wrap="square" lIns="137160" tIns="137160" rIns="137160"/>
-          <a:lstStyle/>
-          <a:p>
-            <a:pPr algn="ctr"/>
-            <a:r>
-              <a:rPr b="1" sz="1500">
-                <a:solidFill>
-                  <a:srgbClr val="FFFFFF"/>
-                </a:solidFill>
-                <a:latin typeface="Arial"/>
-              </a:rPr>
-              <a:t>Phase 3
-Install &amp; QA</a:t>
-            </a:r>
-          </a:p>
-          <a:p>
-            <a:pPr algn="ctr"/>
-            <a:r>
-              <a:rPr sz="1100">
-                <a:solidFill>
-                  <a:srgbClr val="FFFFFF"/>
-                </a:solidFill>
-                <a:latin typeface="Arial"/>
-              </a:rPr>
-              <a:t>Manage certified contractor network for installation; perform install QA; commission fleet onto dispatch software</a:t>
-            </a:r>
-          </a:p>
-          <a:p>
-            <a:pPr algn="ctr"/>
-            <a:r>
-              <a:rPr sz="1100" b="1" i="1">
-                <a:solidFill>
-                  <a:srgbClr val="FFFFFF"/>
-                </a:solidFill>
-                <a:latin typeface="Arial"/>
-              </a:rPr>
-              <a:t>12-24 mo</a:t>
-            </a:r>
-          </a:p>
-        </p:txBody>
-      </p:sp>
-      <p:sp>
-        <p:nvSpPr>
-          <p:cNvPr id="7" name="Rectangle 6"/>
-          <p:cNvSpPr/>
-          <p:nvPr/>
-        </p:nvSpPr>
-        <p:spPr>
-          <a:xfrm>
-            <a:off x="8686800" y="1508760"/>
-            <a:ext cx="2606040" cy="2606040"/>
-          </a:xfrm>
-          <a:prstGeom prst="rect">
-            <a:avLst/>
-          </a:prstGeom>
-          <a:solidFill>
-            <a:srgbClr val="E87B22"/>
-          </a:solidFill>
-          <a:ln>
-            <a:noFill/>
-          </a:ln>
-        </p:spPr>
-        <p:style>
-          <a:lnRef idx="1">
-            <a:schemeClr val="accent1"/>
-          </a:lnRef>
-          <a:fillRef idx="3">
-            <a:schemeClr val="accent1"/>
-          </a:fillRef>
-          <a:effectRef idx="2">
-            <a:schemeClr val="accent1"/>
-          </a:effectRef>
-          <a:fontRef idx="minor">
-            <a:schemeClr val="lt1"/>
-          </a:fontRef>
-        </p:style>
-        <p:txBody>
-          <a:bodyPr rtlCol="0" anchor="ctr" wrap="square" lIns="137160" tIns="137160" rIns="137160"/>
-          <a:lstStyle/>
-          <a:p>
-            <a:pPr algn="ctr"/>
-            <a:r>
-              <a:rPr b="1" sz="1500">
-                <a:solidFill>
-                  <a:srgbClr val="FFFFFF"/>
-                </a:solidFill>
-                <a:latin typeface="Arial"/>
-              </a:rPr>
-              <a:t>Phase 4
-Operate &amp; Report</a:t>
-            </a:r>
-          </a:p>
-          <a:p>
-            <a:pPr algn="ctr"/>
-            <a:r>
-              <a:rPr sz="1100">
-                <a:solidFill>
-                  <a:srgbClr val="FFFFFF"/>
-                </a:solidFill>
-                <a:latin typeface="Arial"/>
-              </a:rPr>
-              <a:t>Ongoing fleet reporting, compliance documentation, contractor continuity, regulatory filings support</a:t>
-            </a:r>
-          </a:p>
-          <a:p>
-            <a:pPr algn="ctr"/>
-            <a:r>
-              <a:rPr sz="1100" b="1" i="1">
-                <a:solidFill>
-                  <a:srgbClr val="FFFFFF"/>
-                </a:solidFill>
-                <a:latin typeface="Arial"/>
-              </a:rPr>
-              <a:t>24 mo+</a:t>
-            </a:r>
-          </a:p>
-        </p:txBody>
-      </p:sp>
-      <p:sp>
-        <p:nvSpPr>
-          <p:cNvPr id="8" name="TextBox 7"/>
-          <p:cNvSpPr txBox="1"/>
-          <p:nvPr/>
-        </p:nvSpPr>
-        <p:spPr>
-          <a:xfrm>
-            <a:off x="2880360" y="2468880"/>
-            <a:ext cx="320040" cy="457200"/>
-          </a:xfrm>
-          <a:prstGeom prst="rect">
-            <a:avLst/>
-          </a:prstGeom>
-          <a:noFill/>
-        </p:spPr>
-        <p:txBody>
-          <a:bodyPr wrap="none">
-            <a:spAutoFit/>
-          </a:bodyPr>
-          <a:lstStyle/>
-          <a:p>
-            <a:pPr algn="ctr"/>
-            <a:r>
-              <a:rPr sz="2200" b="1">
-                <a:solidFill>
-                  <a:srgbClr val="1B2A5E"/>
-                </a:solidFill>
-              </a:rPr>
-              <a:t>→</a:t>
-            </a:r>
-          </a:p>
-        </p:txBody>
-      </p:sp>
-      <p:sp>
-        <p:nvSpPr>
-          <p:cNvPr id="9" name="TextBox 8"/>
-          <p:cNvSpPr txBox="1"/>
-          <p:nvPr/>
-        </p:nvSpPr>
-        <p:spPr>
-          <a:xfrm>
-            <a:off x="5623560" y="2468880"/>
-            <a:ext cx="320040" cy="457200"/>
-          </a:xfrm>
-          <a:prstGeom prst="rect">
-            <a:avLst/>
-          </a:prstGeom>
-          <a:noFill/>
-        </p:spPr>
-        <p:txBody>
-          <a:bodyPr wrap="none">
-            <a:spAutoFit/>
-          </a:bodyPr>
-          <a:lstStyle/>
-          <a:p>
-            <a:pPr algn="ctr"/>
-            <a:r>
-              <a:rPr sz="2200" b="1">
-                <a:solidFill>
-                  <a:srgbClr val="1B2A5E"/>
-                </a:solidFill>
-              </a:rPr>
-              <a:t>→</a:t>
-            </a:r>
-          </a:p>
-        </p:txBody>
-      </p:sp>
-      <p:sp>
-        <p:nvSpPr>
-          <p:cNvPr id="10" name="TextBox 9"/>
-          <p:cNvSpPr txBox="1"/>
-          <p:nvPr/>
-        </p:nvSpPr>
-        <p:spPr>
-          <a:xfrm>
-            <a:off x="8366760" y="2468880"/>
-            <a:ext cx="320040" cy="457200"/>
-          </a:xfrm>
-          <a:prstGeom prst="rect">
-            <a:avLst/>
-          </a:prstGeom>
-          <a:noFill/>
-        </p:spPr>
-        <p:txBody>
-          <a:bodyPr wrap="none">
-            <a:spAutoFit/>
-          </a:bodyPr>
-          <a:lstStyle/>
-          <a:p>
-            <a:pPr algn="ctr"/>
-            <a:r>
-              <a:rPr sz="2200" b="1">
-                <a:solidFill>
-                  <a:srgbClr val="1B2A5E"/>
-                </a:solidFill>
-              </a:rPr>
-              <a:t>→</a:t>
-            </a:r>
-          </a:p>
-        </p:txBody>
-      </p:sp>
-      <p:sp>
-        <p:nvSpPr>
-          <p:cNvPr id="11" name="TextBox 10"/>
-          <p:cNvSpPr txBox="1"/>
-          <p:nvPr/>
-        </p:nvSpPr>
-        <p:spPr>
-          <a:xfrm>
-            <a:off x="457200" y="4343400"/>
-            <a:ext cx="11247120" cy="320040"/>
-          </a:xfrm>
-          <a:prstGeom prst="rect">
-            <a:avLst/>
-          </a:prstGeom>
-          <a:noFill/>
-        </p:spPr>
-        <p:txBody>
-          <a:bodyPr wrap="none">
-            <a:spAutoFit/>
-          </a:bodyPr>
-          <a:lstStyle/>
-          <a:p>
-            <a:r>
-              <a:rPr b="1" sz="1400">
-                <a:solidFill>
-                  <a:srgbClr val="E87B22"/>
-                </a:solidFill>
-                <a:latin typeface="Arial"/>
-              </a:rPr>
-              <a:t>Division of Responsibility Throughout</a:t>
-            </a:r>
-          </a:p>
-        </p:txBody>
-      </p:sp>
-      <p:sp>
-        <p:nvSpPr>
-          <p:cNvPr id="12" name="TextBox 11"/>
-          <p:cNvSpPr txBox="1"/>
-          <p:nvPr/>
-        </p:nvSpPr>
-        <p:spPr>
-          <a:xfrm>
-            <a:off x="457200" y="4709160"/>
-            <a:ext cx="5486400" cy="1463040"/>
-          </a:xfrm>
-          <a:prstGeom prst="rect">
-            <a:avLst/>
-          </a:prstGeom>
-          <a:noFill/>
-        </p:spPr>
-        <p:txBody>
-          <a:bodyPr wrap="square">
-            <a:spAutoFit/>
-          </a:bodyPr>
-          <a:lstStyle/>
-          <a:p>
-            <a:pPr>
-              <a:spcAft>
-                <a:spcPts val="400"/>
-              </a:spcAft>
-            </a:pPr>
-            <a:r>
-              <a:rPr b="1" sz="1200">
-                <a:solidFill>
-                  <a:srgbClr val="1B2A5E"/>
-                </a:solidFill>
-                <a:latin typeface="Arial"/>
-              </a:rPr>
-              <a:t>APTIM Owns (all 4 phases)</a:t>
-            </a:r>
-            <a:r>
-              <a:rPr sz="1100">
-                <a:solidFill>
-                  <a:srgbClr val="333333"/>
-                </a:solidFill>
-                <a:latin typeface="Arial"/>
-              </a:rPr>
-              <a:t>• Program administration &amp; compliance reporting</a:t>
-            </a:r>
-          </a:p>
-          <a:p>
-            <a:pPr>
-              <a:spcAft>
-                <a:spcPts val="400"/>
-              </a:spcAft>
-            </a:pPr>
-            <a:r>
-              <a:rPr sz="1100">
-                <a:solidFill>
-                  <a:srgbClr val="333333"/>
-                </a:solidFill>
-                <a:latin typeface="Arial"/>
-              </a:rPr>
-              <a:t>• Contractor network management &amp; install QA</a:t>
-            </a:r>
-          </a:p>
-          <a:p>
-            <a:pPr>
-              <a:spcAft>
-                <a:spcPts val="400"/>
-              </a:spcAft>
-            </a:pPr>
-            <a:r>
-              <a:rPr sz="1100">
-                <a:solidFill>
-                  <a:srgbClr val="333333"/>
-                </a:solidFill>
-                <a:latin typeface="Arial"/>
-              </a:rPr>
-              <a:t>• Household recruitment &amp; hosting agreements</a:t>
-            </a:r>
-          </a:p>
-          <a:p>
-            <a:pPr>
-              <a:spcAft>
-                <a:spcPts val="400"/>
-              </a:spcAft>
-            </a:pPr>
-            <a:r>
-              <a:rPr sz="1100">
-                <a:solidFill>
-                  <a:srgbClr val="333333"/>
-                </a:solidFill>
-                <a:latin typeface="Arial"/>
-              </a:rPr>
-              <a:t>• Utility relationship &amp; regulatory filings support</a:t>
-            </a:r>
-          </a:p>
-        </p:txBody>
-      </p:sp>
-      <p:sp>
-        <p:nvSpPr>
-          <p:cNvPr id="13" name="TextBox 12"/>
-          <p:cNvSpPr txBox="1"/>
-          <p:nvPr/>
-        </p:nvSpPr>
-        <p:spPr>
-          <a:xfrm>
-            <a:off x="6217920" y="4709160"/>
-            <a:ext cx="5486400" cy="1463040"/>
-          </a:xfrm>
-          <a:prstGeom prst="rect">
-            <a:avLst/>
-          </a:prstGeom>
-          <a:noFill/>
-        </p:spPr>
-        <p:txBody>
-          <a:bodyPr wrap="square">
-            <a:spAutoFit/>
-          </a:bodyPr>
-          <a:lstStyle/>
-          <a:p>
-            <a:pPr>
-              <a:spcAft>
-                <a:spcPts val="400"/>
-              </a:spcAft>
-            </a:pPr>
-            <a:r>
-              <a:rPr b="1" sz="1200">
-                <a:solidFill>
-                  <a:srgbClr val="1B2A5E"/>
-                </a:solidFill>
-                <a:latin typeface="Arial"/>
-              </a:rPr>
-              <a:t>Utility Owns (throughout)</a:t>
-            </a:r>
-            <a:r>
-              <a:rPr sz="1100">
-                <a:solidFill>
-                  <a:srgbClr val="333333"/>
-                </a:solidFill>
-                <a:latin typeface="Arial"/>
-              </a:rPr>
-              <a:t>• Capital investment &amp; fleet ownership (rate-based)</a:t>
-            </a:r>
-          </a:p>
-          <a:p>
-            <a:pPr>
-              <a:spcAft>
-                <a:spcPts val="400"/>
-              </a:spcAft>
-            </a:pPr>
-            <a:r>
-              <a:rPr sz="1100">
-                <a:solidFill>
-                  <a:srgbClr val="333333"/>
-                </a:solidFill>
-                <a:latin typeface="Arial"/>
-              </a:rPr>
-              <a:t>• Regulatory approval / rate case</a:t>
-            </a:r>
-          </a:p>
-          <a:p>
-            <a:pPr>
-              <a:spcAft>
-                <a:spcPts val="400"/>
-              </a:spcAft>
-            </a:pPr>
-            <a:r>
-              <a:rPr sz="1100">
-                <a:solidFill>
-                  <a:srgbClr val="333333"/>
-                </a:solidFill>
-                <a:latin typeface="Arial"/>
-              </a:rPr>
-              <a:t>• Dispatch decisions (via software partner)</a:t>
-            </a:r>
-          </a:p>
-          <a:p>
-            <a:pPr>
-              <a:spcAft>
-                <a:spcPts val="400"/>
-              </a:spcAft>
-            </a:pPr>
-            <a:r>
-              <a:rPr sz="1100">
-                <a:solidFill>
-                  <a:srgbClr val="333333"/>
-                </a:solidFill>
-                <a:latin typeface="Arial"/>
-              </a:rPr>
-              <a:t>• Ratepayer billing &amp; cost recovery</a:t>
-            </a:r>
-          </a:p>
-        </p:txBody>
-      </p:sp>
-      <p:sp>
-        <p:nvSpPr>
-          <p:cNvPr id="14" name="Rectangle 13"/>
-          <p:cNvSpPr/>
-          <p:nvPr/>
-        </p:nvSpPr>
-        <p:spPr>
-          <a:xfrm>
-            <a:off x="457200" y="6263640"/>
-            <a:ext cx="11247120" cy="365760"/>
-          </a:xfrm>
-          <a:prstGeom prst="rect">
-            <a:avLst/>
-          </a:prstGeom>
-          <a:solidFill>
-            <a:srgbClr val="FFF6E8"/>
-          </a:solidFill>
-          <a:ln w="12700">
-            <a:solidFill>
-              <a:srgbClr val="E87B22"/>
-            </a:solidFill>
-          </a:ln>
-        </p:spPr>
-        <p:style>
-          <a:lnRef idx="1">
-            <a:schemeClr val="accent1"/>
-          </a:lnRef>
-          <a:fillRef idx="3">
-            <a:schemeClr val="accent1"/>
-          </a:fillRef>
-          <a:effectRef idx="2">
-            <a:schemeClr val="accent1"/>
-          </a:effectRef>
-          <a:fontRef idx="minor">
-            <a:schemeClr val="lt1"/>
-          </a:fontRef>
-        </p:style>
-        <p:txBody>
-          <a:bodyPr rtlCol="0" anchor="ctr" wrap="square" lIns="137160" tIns="91440"/>
-          <a:lstStyle/>
-          <a:p>
-            <a:pPr algn="ctr"/>
-            <a:r>
-              <a:rPr sz="1000" i="1">
-                <a:solidFill>
-                  <a:srgbClr val="664E1A"/>
-                </a:solidFill>
-                <a:latin typeface="Arial"/>
-              </a:rPr>
-              <a:t>APTIM never owns hardware or takes on capital risk at any phase — consistent with its existing role in Focus on Energy and Entergy Energy Smart.</a:t>
-            </a:r>
-          </a:p>
-        </p:txBody>
-      </p:sp>
-      <p:sp>
-        <p:nvSpPr>
-          <p:cNvPr id="15" name="TextBox 14"/>
-          <p:cNvSpPr txBox="1"/>
-          <p:nvPr/>
-        </p:nvSpPr>
-        <p:spPr>
-          <a:xfrm>
-            <a:off x="274320" y="6492240"/>
-            <a:ext cx="9144000" cy="274320"/>
-          </a:xfrm>
-          <a:prstGeom prst="rect">
-            <a:avLst/>
-          </a:prstGeom>
-          <a:noFill/>
-        </p:spPr>
-        <p:txBody>
-          <a:bodyPr wrap="none">
-            <a:spAutoFit/>
-          </a:bodyPr>
-          <a:lstStyle/>
-          <a:p>
-            <a:r>
-              <a:rPr sz="800">
-                <a:solidFill>
-                  <a:srgbClr val="888888"/>
-                </a:solidFill>
-                <a:latin typeface="Arial"/>
-              </a:rPr>
-              <a:t>Confidential. Not to be copied, distributed, or reproduced without prior approval. © 2026 APTIM - All rights reserved.</a:t>
-            </a:r>
-          </a:p>
-        </p:txBody>
-      </p:sp>
-      <p:sp>
-        <p:nvSpPr>
-          <p:cNvPr id="16" name="TextBox 15"/>
-          <p:cNvSpPr txBox="1"/>
-          <p:nvPr/>
-        </p:nvSpPr>
-        <p:spPr>
-          <a:xfrm>
-            <a:off x="11612880" y="6492240"/>
-            <a:ext cx="457200" cy="274320"/>
-          </a:xfrm>
-          <a:prstGeom prst="rect">
-            <a:avLst/>
-          </a:prstGeom>
-          <a:noFill/>
-        </p:spPr>
-        <p:txBody>
-          <a:bodyPr wrap="none">
-            <a:spAutoFit/>
-          </a:bodyPr>
-          <a:lstStyle/>
-          <a:p>
-            <a:r>
-              <a:rPr sz="800">
-                <a:solidFill>
-                  <a:srgbClr val="888888"/>
-                </a:solidFill>
-                <a:latin typeface="Arial"/>
-              </a:rPr>
-              <a:t>1</a:t>
-            </a:r>
-          </a:p>
-        </p:txBody>
-      </p:sp>
-    </p:spTree>
-  </p:cSld>
-  <p:clrMapOvr>
-    <a:masterClrMapping/>
-  </p:clrMapOvr>
-</p:sld>
-</file>
-
-<file path=ppt/slides/slide2.xml><?xml version="1.0" encoding="utf-8"?>
-<p:sld xmlns:a="http://schemas.openxmlformats.org/drawingml/2006/main" xmlns:p="http://schemas.openxmlformats.org/presentationml/2006/main" xmlns:r="http://schemas.openxmlformats.org/officeDocument/2006/relationships">
-  <p:cSld>
-    <p:spTree>
-      <p:nvGrpSpPr>
-        <p:cNvPr id="1" name=""/>
-        <p:cNvGrpSpPr/>
-        <p:nvPr/>
-      </p:nvGrpSpPr>
-      <p:grpSpPr/>
-      <p:sp>
-        <p:nvSpPr>
-          <p:cNvPr id="2" name="TextBox 1"/>
-          <p:cNvSpPr txBox="1"/>
-          <p:nvPr/>
-        </p:nvSpPr>
-        <p:spPr>
-          <a:xfrm>
-            <a:off x="457200" y="228600"/>
-            <a:ext cx="11247120" cy="731520"/>
-          </a:xfrm>
-          <a:prstGeom prst="rect">
-            <a:avLst/>
-          </a:prstGeom>
-          <a:noFill/>
-        </p:spPr>
-        <p:txBody>
-          <a:bodyPr wrap="square">
-            <a:spAutoFit/>
-          </a:bodyPr>
-          <a:lstStyle/>
-          <a:p>
-            <a:r>
-              <a:rPr sz="2600" b="1">
-                <a:solidFill>
-                  <a:srgbClr val="1B2A5E"/>
-                </a:solidFill>
-                <a:latin typeface="Arial"/>
-              </a:rPr>
-              <a:t>Service Concept: The APTIM Operating Model</a:t>
-            </a:r>
-          </a:p>
-        </p:txBody>
-      </p:sp>
-      <p:sp>
-        <p:nvSpPr>
-          <p:cNvPr id="3" name="TextBox 2"/>
-          <p:cNvSpPr txBox="1"/>
-          <p:nvPr/>
-        </p:nvSpPr>
-        <p:spPr>
-          <a:xfrm>
-            <a:off x="457200" y="914400"/>
-            <a:ext cx="11247120" cy="365760"/>
-          </a:xfrm>
-          <a:prstGeom prst="rect">
-            <a:avLst/>
-          </a:prstGeom>
-          <a:noFill/>
-        </p:spPr>
-        <p:txBody>
-          <a:bodyPr wrap="none">
-            <a:spAutoFit/>
-          </a:bodyPr>
-          <a:lstStyle/>
-          <a:p>
-            <a:r>
-              <a:rPr sz="1400" i="1">
-                <a:solidFill>
-                  <a:srgbClr val="777777"/>
-                </a:solidFill>
-                <a:latin typeface="Arial"/>
-              </a:rPr>
-              <a:t>The utility owns the fleet. APTIM runs the program. The household hosts it at no cost.</a:t>
-            </a:r>
-          </a:p>
-        </p:txBody>
-      </p:sp>
-      <p:sp>
-        <p:nvSpPr>
-          <p:cNvPr id="4" name="Rectangle 3"/>
-          <p:cNvSpPr/>
-          <p:nvPr/>
-        </p:nvSpPr>
-        <p:spPr>
-          <a:xfrm>
-            <a:off x="457200" y="1371600"/>
-            <a:ext cx="3520440" cy="1371600"/>
-          </a:xfrm>
-          <a:prstGeom prst="rect">
-            <a:avLst/>
-          </a:prstGeom>
-          <a:solidFill>
-            <a:srgbClr val="8A8A8A"/>
-          </a:solidFill>
-          <a:ln>
-            <a:noFill/>
-          </a:ln>
-        </p:spPr>
-        <p:style>
-          <a:lnRef idx="1">
-            <a:schemeClr val="accent1"/>
-          </a:lnRef>
-          <a:fillRef idx="3">
-            <a:schemeClr val="accent1"/>
-          </a:fillRef>
-          <a:effectRef idx="2">
-            <a:schemeClr val="accent1"/>
-          </a:effectRef>
-          <a:fontRef idx="minor">
-            <a:schemeClr val="lt1"/>
-          </a:fontRef>
-        </p:style>
-        <p:txBody>
-          <a:bodyPr rtlCol="0" anchor="ctr" wrap="square" lIns="137160" tIns="109728" rIns="137160"/>
-          <a:lstStyle/>
-          <a:p>
-            <a:pPr algn="ctr"/>
-            <a:r>
-              <a:rPr b="1" sz="1300">
-                <a:solidFill>
-                  <a:srgbClr val="FFFFFF"/>
-                </a:solidFill>
-                <a:latin typeface="Arial"/>
-              </a:rPr>
-              <a:t>Hardware Maker</a:t>
-            </a:r>
-          </a:p>
-          <a:p>
-            <a:pPr algn="ctr"/>
-            <a:r>
-              <a:rPr b="1" sz="1200">
-                <a:solidFill>
-                  <a:srgbClr val="FFFFFF"/>
-                </a:solidFill>
-                <a:latin typeface="Arial"/>
-              </a:rPr>
-              <a:t>e.g., Tesla, Enphase</a:t>
-            </a:r>
-          </a:p>
-          <a:p>
-            <a:pPr algn="ctr"/>
-            <a:r>
-              <a:rPr sz="1000">
-                <a:solidFill>
-                  <a:srgbClr val="FFFFFF"/>
-                </a:solidFill>
-                <a:latin typeface="Arial"/>
-              </a:rPr>
-              <a:t>Manufactures battery + solar hardware</a:t>
-            </a:r>
-          </a:p>
-        </p:txBody>
-      </p:sp>
-      <p:sp>
-        <p:nvSpPr>
-          <p:cNvPr id="5" name="Rectangle 4"/>
-          <p:cNvSpPr/>
-          <p:nvPr/>
-        </p:nvSpPr>
-        <p:spPr>
-          <a:xfrm>
-            <a:off x="4114800" y="1371600"/>
-            <a:ext cx="3520440" cy="1371600"/>
-          </a:xfrm>
-          <a:prstGeom prst="rect">
-            <a:avLst/>
-          </a:prstGeom>
-          <a:solidFill>
-            <a:srgbClr val="1B2A5E"/>
-          </a:solidFill>
-          <a:ln>
-            <a:noFill/>
-          </a:ln>
-        </p:spPr>
-        <p:style>
-          <a:lnRef idx="1">
-            <a:schemeClr val="accent1"/>
-          </a:lnRef>
-          <a:fillRef idx="3">
-            <a:schemeClr val="accent1"/>
-          </a:fillRef>
-          <a:effectRef idx="2">
-            <a:schemeClr val="accent1"/>
-          </a:effectRef>
-          <a:fontRef idx="minor">
-            <a:schemeClr val="lt1"/>
-          </a:fontRef>
-        </p:style>
-        <p:txBody>
-          <a:bodyPr rtlCol="0" anchor="ctr" wrap="square" lIns="137160" tIns="109728" rIns="137160"/>
-          <a:lstStyle/>
-          <a:p>
-            <a:pPr algn="ctr"/>
-            <a:r>
-              <a:rPr b="1" sz="1300">
-                <a:solidFill>
-                  <a:srgbClr val="FFFFFF"/>
-                </a:solidFill>
-                <a:latin typeface="Arial"/>
-              </a:rPr>
-              <a:t>Asset Owner + Dispatcher</a:t>
-            </a:r>
-          </a:p>
-          <a:p>
-            <a:pPr algn="ctr"/>
-            <a:r>
-              <a:rPr b="1" sz="1200">
-                <a:solidFill>
-                  <a:srgbClr val="FFFFFF"/>
-                </a:solidFill>
-                <a:latin typeface="Arial"/>
-              </a:rPr>
-              <a:t>The Utility</a:t>
-            </a:r>
-          </a:p>
-          <a:p>
-            <a:pPr algn="ctr"/>
-            <a:r>
-              <a:rPr sz="1000">
-                <a:solidFill>
-                  <a:srgbClr val="FFFFFF"/>
-                </a:solidFill>
-                <a:latin typeface="Arial"/>
-              </a:rPr>
-              <a:t>Finances, owns, rate-bases the fleet; earns regulated return; dispatches via software partner</a:t>
-            </a:r>
-          </a:p>
-        </p:txBody>
-      </p:sp>
-      <p:sp>
-        <p:nvSpPr>
-          <p:cNvPr id="6" name="Rectangle 5"/>
-          <p:cNvSpPr/>
-          <p:nvPr/>
-        </p:nvSpPr>
-        <p:spPr>
-          <a:xfrm>
-            <a:off x="7772400" y="1371600"/>
-            <a:ext cx="3520440" cy="1371600"/>
-          </a:xfrm>
-          <a:prstGeom prst="rect">
-            <a:avLst/>
-          </a:prstGeom>
-          <a:solidFill>
-            <a:srgbClr val="E87B22"/>
-          </a:solidFill>
-          <a:ln>
-            <a:noFill/>
-          </a:ln>
-        </p:spPr>
-        <p:style>
-          <a:lnRef idx="1">
-            <a:schemeClr val="accent1"/>
-          </a:lnRef>
-          <a:fillRef idx="3">
-            <a:schemeClr val="accent1"/>
-          </a:fillRef>
-          <a:effectRef idx="2">
-            <a:schemeClr val="accent1"/>
-          </a:effectRef>
-          <a:fontRef idx="minor">
-            <a:schemeClr val="lt1"/>
-          </a:fontRef>
-        </p:style>
-        <p:txBody>
           <a:bodyPr rtlCol="0" anchor="ctr" wrap="square" lIns="137160" tIns="109728" rIns="137160"/>
           <a:lstStyle/>
           <a:p>
@@ -4224,7 +4154,7 @@
                 </a:solidFill>
                 <a:latin typeface="Arial"/>
               </a:rPr>
-              <a:t>Runs the program end-to-end — see implementation phases</a:t>
+              <a:t>Site selection, recruitment, hosting agreements, contractor network, install QA, fleet reporting, compliance</a:t>
             </a:r>
           </a:p>
         </p:txBody>

</xml_diff>